<commit_message>
Update WPMS Progress Presentation.pptx
Finalized Project Presentation slides
</commit_message>
<xml_diff>
--- a/Documentation/Preparation/WPMS Progress Presentation.pptx
+++ b/Documentation/Preparation/WPMS Progress Presentation.pptx
@@ -17,19 +17,25 @@
     <p:sldId id="263" r:id="rId11"/>
     <p:sldId id="264" r:id="rId12"/>
     <p:sldId id="265" r:id="rId13"/>
-    <p:sldId id="266" r:id="rId14"/>
-    <p:sldId id="267" r:id="rId15"/>
-    <p:sldId id="268" r:id="rId16"/>
-    <p:sldId id="269" r:id="rId17"/>
-    <p:sldId id="270" r:id="rId18"/>
-    <p:sldId id="273" r:id="rId19"/>
-    <p:sldId id="276" r:id="rId20"/>
-    <p:sldId id="274" r:id="rId21"/>
-    <p:sldId id="275" r:id="rId22"/>
-    <p:sldId id="277" r:id="rId23"/>
-    <p:sldId id="278" r:id="rId24"/>
-    <p:sldId id="279" r:id="rId25"/>
-    <p:sldId id="280" r:id="rId26"/>
+    <p:sldId id="287" r:id="rId14"/>
+    <p:sldId id="266" r:id="rId15"/>
+    <p:sldId id="267" r:id="rId16"/>
+    <p:sldId id="268" r:id="rId17"/>
+    <p:sldId id="269" r:id="rId18"/>
+    <p:sldId id="270" r:id="rId19"/>
+    <p:sldId id="273" r:id="rId20"/>
+    <p:sldId id="276" r:id="rId21"/>
+    <p:sldId id="274" r:id="rId22"/>
+    <p:sldId id="275" r:id="rId23"/>
+    <p:sldId id="277" r:id="rId24"/>
+    <p:sldId id="278" r:id="rId25"/>
+    <p:sldId id="286" r:id="rId26"/>
+    <p:sldId id="282" r:id="rId27"/>
+    <p:sldId id="283" r:id="rId28"/>
+    <p:sldId id="284" r:id="rId29"/>
+    <p:sldId id="285" r:id="rId30"/>
+    <p:sldId id="279" r:id="rId31"/>
+    <p:sldId id="280" r:id="rId32"/>
   </p:sldIdLst>
   <p:sldSz cx="12192000" cy="6858000"/>
   <p:notesSz cx="6858000" cy="9144000"/>
@@ -136,6 +142,18 @@
 </p:presentation>
 </file>
 
+<file path=ppt/commentAuthors.xml><?xml version="1.0" encoding="utf-8"?>
+<p:cmAuthorLst xmlns:a="http://schemas.openxmlformats.org/drawingml/2006/main" xmlns:r="http://schemas.openxmlformats.org/officeDocument/2006/relationships" xmlns:p="http://schemas.openxmlformats.org/presentationml/2006/main">
+  <p:cmAuthor id="1" name="LENOVO" initials="L" lastIdx="5" clrIdx="0">
+    <p:extLst>
+      <p:ext uri="{19B8F6BF-5375-455C-9EA6-DF929625EA0E}">
+        <p15:presenceInfo xmlns:p15="http://schemas.microsoft.com/office/powerpoint/2012/main" userId="LENOVO" providerId="None"/>
+      </p:ext>
+    </p:extLst>
+  </p:cmAuthor>
+</p:cmAuthorLst>
+</file>
+
 <file path=ppt/slideLayouts/slideLayout1.xml><?xml version="1.0" encoding="utf-8"?>
 <p:sldLayout xmlns:a="http://schemas.openxmlformats.org/drawingml/2006/main" xmlns:r="http://schemas.openxmlformats.org/officeDocument/2006/relationships" xmlns:p="http://schemas.openxmlformats.org/presentationml/2006/main" showMasterSp="0" type="title" preserve="1">
   <p:cSld name="Title Slide">
@@ -539,7 +557,7 @@
           <a:p>
             <a:fld id="{943DC3CD-1FBD-4175-A49E-C6F4C28120C4}" type="datetimeFigureOut">
               <a:rPr lang="en-US" smtClean="0"/>
-              <a:t>9/20/2026</a:t>
+              <a:t>10/2/2026</a:t>
             </a:fld>
             <a:endParaRPr lang="en-US" dirty="0"/>
           </a:p>
@@ -718,7 +736,7 @@
           <a:p>
             <a:fld id="{943DC3CD-1FBD-4175-A49E-C6F4C28120C4}" type="datetimeFigureOut">
               <a:rPr lang="en-US" smtClean="0"/>
-              <a:t>9/20/2026</a:t>
+              <a:t>10/2/2026</a:t>
             </a:fld>
             <a:endParaRPr lang="en-US" dirty="0"/>
           </a:p>
@@ -898,7 +916,7 @@
           <a:p>
             <a:fld id="{943DC3CD-1FBD-4175-A49E-C6F4C28120C4}" type="datetimeFigureOut">
               <a:rPr lang="en-US" smtClean="0"/>
-              <a:t>9/20/2026</a:t>
+              <a:t>10/2/2026</a:t>
             </a:fld>
             <a:endParaRPr lang="en-US" dirty="0"/>
           </a:p>
@@ -1068,7 +1086,7 @@
           <a:p>
             <a:fld id="{943DC3CD-1FBD-4175-A49E-C6F4C28120C4}" type="datetimeFigureOut">
               <a:rPr lang="en-US" smtClean="0"/>
-              <a:t>9/20/2026</a:t>
+              <a:t>10/2/2026</a:t>
             </a:fld>
             <a:endParaRPr lang="en-US" dirty="0"/>
           </a:p>
@@ -1381,7 +1399,7 @@
           <a:p>
             <a:fld id="{943DC3CD-1FBD-4175-A49E-C6F4C28120C4}" type="datetimeFigureOut">
               <a:rPr lang="en-US" smtClean="0"/>
-              <a:t>9/20/2026</a:t>
+              <a:t>10/2/2026</a:t>
             </a:fld>
             <a:endParaRPr lang="en-US" dirty="0"/>
           </a:p>
@@ -1767,7 +1785,7 @@
           <a:p>
             <a:fld id="{943DC3CD-1FBD-4175-A49E-C6F4C28120C4}" type="datetimeFigureOut">
               <a:rPr lang="en-US" smtClean="0"/>
-              <a:t>9/20/2026</a:t>
+              <a:t>10/2/2026</a:t>
             </a:fld>
             <a:endParaRPr lang="en-US" dirty="0"/>
           </a:p>
@@ -2201,7 +2219,7 @@
           <a:p>
             <a:fld id="{943DC3CD-1FBD-4175-A49E-C6F4C28120C4}" type="datetimeFigureOut">
               <a:rPr lang="en-US" smtClean="0"/>
-              <a:t>9/20/2026</a:t>
+              <a:t>10/2/2026</a:t>
             </a:fld>
             <a:endParaRPr lang="en-US" dirty="0"/>
           </a:p>
@@ -2319,7 +2337,7 @@
           <a:p>
             <a:fld id="{943DC3CD-1FBD-4175-A49E-C6F4C28120C4}" type="datetimeFigureOut">
               <a:rPr lang="en-US" smtClean="0"/>
-              <a:t>9/20/2026</a:t>
+              <a:t>10/2/2026</a:t>
             </a:fld>
             <a:endParaRPr lang="en-US" dirty="0"/>
           </a:p>
@@ -2414,7 +2432,7 @@
           <a:p>
             <a:fld id="{943DC3CD-1FBD-4175-A49E-C6F4C28120C4}" type="datetimeFigureOut">
               <a:rPr lang="en-US" smtClean="0"/>
-              <a:t>9/20/2026</a:t>
+              <a:t>10/2/2026</a:t>
             </a:fld>
             <a:endParaRPr lang="en-US" dirty="0"/>
           </a:p>
@@ -2764,7 +2782,7 @@
           <a:p>
             <a:fld id="{943DC3CD-1FBD-4175-A49E-C6F4C28120C4}" type="datetimeFigureOut">
               <a:rPr lang="en-US" smtClean="0"/>
-              <a:t>9/20/2026</a:t>
+              <a:t>10/2/2026</a:t>
             </a:fld>
             <a:endParaRPr lang="en-US" dirty="0"/>
           </a:p>
@@ -3188,7 +3206,7 @@
           <a:p>
             <a:fld id="{943DC3CD-1FBD-4175-A49E-C6F4C28120C4}" type="datetimeFigureOut">
               <a:rPr lang="en-US" smtClean="0"/>
-              <a:t>9/20/2026</a:t>
+              <a:t>10/2/2026</a:t>
             </a:fld>
             <a:endParaRPr lang="en-US" dirty="0"/>
           </a:p>
@@ -3469,7 +3487,7 @@
           <a:p>
             <a:fld id="{943DC3CD-1FBD-4175-A49E-C6F4C28120C4}" type="datetimeFigureOut">
               <a:rPr lang="en-US" smtClean="0"/>
-              <a:t>9/20/2026</a:t>
+              <a:t>10/2/2026</a:t>
             </a:fld>
             <a:endParaRPr lang="en-US" dirty="0"/>
           </a:p>
@@ -4922,7 +4940,12 @@
             <p:ph type="title"/>
           </p:nvPr>
         </p:nvSpPr>
-        <p:spPr/>
+        <p:spPr>
+          <a:xfrm>
+            <a:off x="8549640" y="2773680"/>
+            <a:ext cx="3200400" cy="655320"/>
+          </a:xfrm>
+        </p:spPr>
         <p:txBody>
           <a:bodyPr/>
           <a:lstStyle/>
@@ -4934,186 +4957,41 @@
           </a:p>
         </p:txBody>
       </p:sp>
-      <p:sp>
-        <p:nvSpPr>
-          <p:cNvPr id="4" name="Rectangle 1">
+      <p:pic>
+        <p:nvPicPr>
+          <p:cNvPr id="7" name="Content Placeholder 6">
             <a:extLst>
               <a:ext uri="{FF2B5EF4-FFF2-40B4-BE49-F238E27FC236}">
-                <a16:creationId xmlns:a16="http://schemas.microsoft.com/office/drawing/2014/main" id="{72EECC24-A6E2-4153-BC28-4697C35DF841}"/>
+                <a16:creationId xmlns:a16="http://schemas.microsoft.com/office/drawing/2014/main" id="{18CB11E6-D1EC-48E8-933B-BDC5EB82EC53}"/>
               </a:ext>
             </a:extLst>
           </p:cNvPr>
-          <p:cNvSpPr>
-            <a:spLocks noGrp="1" noChangeArrowheads="1"/>
-          </p:cNvSpPr>
+          <p:cNvPicPr>
+            <a:picLocks noGrp="1" noChangeAspect="1"/>
+          </p:cNvPicPr>
           <p:nvPr>
             <p:ph idx="1"/>
           </p:nvPr>
-        </p:nvSpPr>
-        <p:spPr bwMode="auto">
+        </p:nvPicPr>
+        <p:blipFill>
+          <a:blip r:embed="rId2">
+            <a:extLst>
+              <a:ext uri="{28A0092B-C50C-407E-A947-70E740481C1C}">
+                <a14:useLocalDpi xmlns:a14="http://schemas.microsoft.com/office/drawing/2010/main" val="0"/>
+              </a:ext>
+            </a:extLst>
+          </a:blip>
+          <a:stretch>
+            <a:fillRect/>
+          </a:stretch>
+        </p:blipFill>
+        <p:spPr>
           <a:xfrm>
-            <a:off x="1069848" y="2765756"/>
-            <a:ext cx="8717771" cy="2741776"/>
+            <a:off x="563880" y="681423"/>
+            <a:ext cx="7143506" cy="5495154"/>
           </a:xfrm>
-          <a:prstGeom prst="rect">
-            <a:avLst/>
-          </a:prstGeom>
-          <a:noFill/>
-          <a:ln>
-            <a:noFill/>
-          </a:ln>
-          <a:effectLst/>
-          <a:extLst>
-            <a:ext uri="{909E8E84-426E-40DD-AFC4-6F175D3DCCD1}">
-              <a14:hiddenFill xmlns:a14="http://schemas.microsoft.com/office/drawing/2010/main">
-                <a:solidFill>
-                  <a:schemeClr val="accent1"/>
-                </a:solidFill>
-              </a14:hiddenFill>
-            </a:ext>
-            <a:ext uri="{91240B29-F687-4F45-9708-019B960494DF}">
-              <a14:hiddenLine xmlns:a14="http://schemas.microsoft.com/office/drawing/2010/main" w="9525">
-                <a:solidFill>
-                  <a:schemeClr val="tx1"/>
-                </a:solidFill>
-                <a:miter lim="800000"/>
-                <a:headEnd/>
-                <a:tailEnd/>
-              </a14:hiddenLine>
-            </a:ext>
-            <a:ext uri="{AF507438-7753-43E0-B8FC-AC1667EBCBE1}">
-              <a14:hiddenEffects xmlns:a14="http://schemas.microsoft.com/office/drawing/2010/main">
-                <a:effectLst>
-                  <a:outerShdw dist="35921" dir="2700000" algn="ctr" rotWithShape="0">
-                    <a:schemeClr val="bg2"/>
-                  </a:outerShdw>
-                </a:effectLst>
-              </a14:hiddenEffects>
-            </a:ext>
-          </a:extLst>
         </p:spPr>
-        <p:txBody>
-          <a:bodyPr vert="horz" wrap="none" lIns="91440" tIns="45720" rIns="91440" bIns="45720" numCol="1" anchor="ctr" anchorCtr="0" compatLnSpc="1">
-            <a:prstTxWarp prst="textNoShape">
-              <a:avLst/>
-            </a:prstTxWarp>
-            <a:spAutoFit/>
-          </a:bodyPr>
-          <a:lstStyle/>
-          <a:p>
-            <a:pPr eaLnBrk="0" fontAlgn="base" hangingPunct="0">
-              <a:lnSpc>
-                <a:spcPct val="250000"/>
-              </a:lnSpc>
-              <a:spcBef>
-                <a:spcPct val="0"/>
-              </a:spcBef>
-              <a:spcAft>
-                <a:spcPct val="0"/>
-              </a:spcAft>
-              <a:buClrTx/>
-              <a:buSzTx/>
-            </a:pPr>
-            <a:r>
-              <a:rPr kumimoji="0" lang="en-US" altLang="en-US" sz="1800" i="0" u="none" strike="noStrike" cap="none" normalizeH="0" baseline="0" dirty="0">
-                <a:ln>
-                  <a:noFill/>
-                </a:ln>
-                <a:solidFill>
-                  <a:schemeClr val="tx1"/>
-                </a:solidFill>
-                <a:effectLst/>
-                <a:latin typeface="Arial" panose="020B0604020202020204" pitchFamily="34" charset="0"/>
-              </a:rPr>
-              <a:t>Waterfall Hybrid SDLC used as the overall development approach </a:t>
-            </a:r>
-          </a:p>
-          <a:p>
-            <a:pPr eaLnBrk="0" fontAlgn="base" hangingPunct="0">
-              <a:lnSpc>
-                <a:spcPct val="250000"/>
-              </a:lnSpc>
-              <a:spcBef>
-                <a:spcPct val="0"/>
-              </a:spcBef>
-              <a:spcAft>
-                <a:spcPct val="0"/>
-              </a:spcAft>
-              <a:buClrTx/>
-              <a:buSzTx/>
-            </a:pPr>
-            <a:r>
-              <a:rPr kumimoji="0" lang="en-US" altLang="en-US" sz="1800" i="0" u="none" strike="noStrike" cap="none" normalizeH="0" baseline="0" dirty="0">
-                <a:ln>
-                  <a:noFill/>
-                </a:ln>
-                <a:solidFill>
-                  <a:schemeClr val="tx1"/>
-                </a:solidFill>
-                <a:effectLst/>
-                <a:latin typeface="Arial" panose="020B0604020202020204" pitchFamily="34" charset="0"/>
-              </a:rPr>
-              <a:t>Requirements were investigated before system design and implementation </a:t>
-            </a:r>
-          </a:p>
-          <a:p>
-            <a:pPr eaLnBrk="0" fontAlgn="base" hangingPunct="0">
-              <a:lnSpc>
-                <a:spcPct val="250000"/>
-              </a:lnSpc>
-              <a:spcBef>
-                <a:spcPct val="0"/>
-              </a:spcBef>
-              <a:spcAft>
-                <a:spcPct val="0"/>
-              </a:spcAft>
-              <a:buClrTx/>
-              <a:buSzTx/>
-            </a:pPr>
-            <a:r>
-              <a:rPr kumimoji="0" lang="en-US" altLang="en-US" sz="1800" i="0" u="none" strike="noStrike" cap="none" normalizeH="0" baseline="0" dirty="0">
-                <a:ln>
-                  <a:noFill/>
-                </a:ln>
-                <a:solidFill>
-                  <a:schemeClr val="tx1"/>
-                </a:solidFill>
-                <a:effectLst/>
-                <a:latin typeface="Arial" panose="020B0604020202020204" pitchFamily="34" charset="0"/>
-              </a:rPr>
-              <a:t>Questionnaire/survey used to gather broader perspectives </a:t>
-            </a:r>
-          </a:p>
-          <a:p>
-            <a:pPr eaLnBrk="0" fontAlgn="base" hangingPunct="0">
-              <a:lnSpc>
-                <a:spcPct val="250000"/>
-              </a:lnSpc>
-              <a:spcBef>
-                <a:spcPct val="0"/>
-              </a:spcBef>
-              <a:spcAft>
-                <a:spcPct val="0"/>
-              </a:spcAft>
-              <a:buClrTx/>
-              <a:buSzTx/>
-            </a:pPr>
-            <a:r>
-              <a:rPr kumimoji="0" lang="en-US" altLang="en-US" sz="1800" i="0" u="none" strike="noStrike" cap="none" normalizeH="0" baseline="0" dirty="0">
-                <a:ln>
-                  <a:noFill/>
-                </a:ln>
-                <a:solidFill>
-                  <a:schemeClr val="tx1"/>
-                </a:solidFill>
-                <a:effectLst/>
-                <a:latin typeface="Arial" panose="020B0604020202020204" pitchFamily="34" charset="0"/>
-              </a:rPr>
-              <a:t>Interview used to explore professional/project-work requirements in greater depth </a:t>
-            </a:r>
-          </a:p>
-        </p:txBody>
-      </p:sp>
+      </p:pic>
     </p:spTree>
     <p:extLst>
       <p:ext uri="{BB962C8B-B14F-4D97-AF65-F5344CB8AC3E}">
@@ -5149,7 +5027,7 @@
           <p:cNvPr id="2" name="Title 1">
             <a:extLst>
               <a:ext uri="{FF2B5EF4-FFF2-40B4-BE49-F238E27FC236}">
-                <a16:creationId xmlns:a16="http://schemas.microsoft.com/office/drawing/2014/main" id="{6E47D36C-9E4B-476F-AC15-C597C7C2A361}"/>
+                <a16:creationId xmlns:a16="http://schemas.microsoft.com/office/drawing/2014/main" id="{621E03CD-01FC-4A00-B10A-BDC77D5F26C7}"/>
               </a:ext>
             </a:extLst>
           </p:cNvPr>
@@ -5160,202 +5038,62 @@
             <p:ph type="title"/>
           </p:nvPr>
         </p:nvSpPr>
-        <p:spPr/>
+        <p:spPr>
+          <a:xfrm>
+            <a:off x="8641080" y="2377440"/>
+            <a:ext cx="3200400" cy="818388"/>
+          </a:xfrm>
+        </p:spPr>
         <p:txBody>
           <a:bodyPr/>
           <a:lstStyle/>
           <a:p>
             <a:r>
               <a:rPr lang="en-US" dirty="0"/>
-              <a:t>Requirements Elicitation</a:t>
-            </a:r>
-          </a:p>
-        </p:txBody>
-      </p:sp>
-      <p:sp>
-        <p:nvSpPr>
-          <p:cNvPr id="4" name="Rectangle 1">
+              <a:t>Gantt Chart</a:t>
+            </a:r>
+          </a:p>
+        </p:txBody>
+      </p:sp>
+      <p:pic>
+        <p:nvPicPr>
+          <p:cNvPr id="5" name="Content Placeholder 4">
             <a:extLst>
               <a:ext uri="{FF2B5EF4-FFF2-40B4-BE49-F238E27FC236}">
-                <a16:creationId xmlns:a16="http://schemas.microsoft.com/office/drawing/2014/main" id="{226A1D72-5045-437B-8F4B-DF9193C2CF49}"/>
+                <a16:creationId xmlns:a16="http://schemas.microsoft.com/office/drawing/2014/main" id="{63832DF4-387D-4076-B42E-24487C947AB7}"/>
               </a:ext>
             </a:extLst>
           </p:cNvPr>
-          <p:cNvSpPr>
-            <a:spLocks noGrp="1" noChangeArrowheads="1"/>
-          </p:cNvSpPr>
+          <p:cNvPicPr>
+            <a:picLocks noGrp="1" noChangeAspect="1"/>
+          </p:cNvPicPr>
           <p:nvPr>
             <p:ph idx="1"/>
           </p:nvPr>
-        </p:nvSpPr>
-        <p:spPr bwMode="auto">
+        </p:nvPicPr>
+        <p:blipFill>
+          <a:blip r:embed="rId2">
+            <a:extLst>
+              <a:ext uri="{28A0092B-C50C-407E-A947-70E740481C1C}">
+                <a14:useLocalDpi xmlns:a14="http://schemas.microsoft.com/office/drawing/2010/main" val="0"/>
+              </a:ext>
+            </a:extLst>
+          </a:blip>
+          <a:stretch>
+            <a:fillRect/>
+          </a:stretch>
+        </p:blipFill>
+        <p:spPr>
           <a:xfrm>
-            <a:off x="1069848" y="2775916"/>
-            <a:ext cx="8666475" cy="2741776"/>
+            <a:off x="475865" y="462534"/>
+            <a:ext cx="7195278" cy="5932932"/>
           </a:xfrm>
-          <a:prstGeom prst="rect">
-            <a:avLst/>
-          </a:prstGeom>
-          <a:noFill/>
-          <a:ln>
-            <a:noFill/>
-          </a:ln>
-          <a:effectLst/>
-          <a:extLst>
-            <a:ext uri="{909E8E84-426E-40DD-AFC4-6F175D3DCCD1}">
-              <a14:hiddenFill xmlns:a14="http://schemas.microsoft.com/office/drawing/2010/main">
-                <a:solidFill>
-                  <a:schemeClr val="accent1"/>
-                </a:solidFill>
-              </a14:hiddenFill>
-            </a:ext>
-            <a:ext uri="{91240B29-F687-4F45-9708-019B960494DF}">
-              <a14:hiddenLine xmlns:a14="http://schemas.microsoft.com/office/drawing/2010/main" w="9525">
-                <a:solidFill>
-                  <a:schemeClr val="tx1"/>
-                </a:solidFill>
-                <a:miter lim="800000"/>
-                <a:headEnd/>
-                <a:tailEnd/>
-              </a14:hiddenLine>
-            </a:ext>
-            <a:ext uri="{AF507438-7753-43E0-B8FC-AC1667EBCBE1}">
-              <a14:hiddenEffects xmlns:a14="http://schemas.microsoft.com/office/drawing/2010/main">
-                <a:effectLst>
-                  <a:outerShdw dist="35921" dir="2700000" algn="ctr" rotWithShape="0">
-                    <a:schemeClr val="bg2"/>
-                  </a:outerShdw>
-                </a:effectLst>
-              </a14:hiddenEffects>
-            </a:ext>
-          </a:extLst>
         </p:spPr>
-        <p:txBody>
-          <a:bodyPr vert="horz" wrap="none" lIns="91440" tIns="45720" rIns="91440" bIns="45720" numCol="1" anchor="ctr" anchorCtr="0" compatLnSpc="1">
-            <a:prstTxWarp prst="textNoShape">
-              <a:avLst/>
-            </a:prstTxWarp>
-            <a:spAutoFit/>
-          </a:bodyPr>
-          <a:lstStyle/>
-          <a:p>
-            <a:pPr eaLnBrk="0" fontAlgn="base" hangingPunct="0">
-              <a:lnSpc>
-                <a:spcPct val="250000"/>
-              </a:lnSpc>
-              <a:spcBef>
-                <a:spcPct val="0"/>
-              </a:spcBef>
-              <a:spcAft>
-                <a:spcPct val="0"/>
-              </a:spcAft>
-              <a:buClrTx/>
-              <a:buSzTx/>
-            </a:pPr>
-            <a:r>
-              <a:rPr kumimoji="0" lang="en-US" altLang="en-US" sz="1800" i="0" u="none" strike="noStrike" cap="none" normalizeH="0" baseline="0" dirty="0">
-                <a:ln>
-                  <a:noFill/>
-                </a:ln>
-                <a:solidFill>
-                  <a:schemeClr val="tx1"/>
-                </a:solidFill>
-                <a:effectLst/>
-                <a:latin typeface="Arial" panose="020B0604020202020204" pitchFamily="34" charset="0"/>
-              </a:rPr>
-              <a:t>Survey focused on people involved in collaborative and individual work </a:t>
-            </a:r>
-          </a:p>
-          <a:p>
-            <a:pPr eaLnBrk="0" fontAlgn="base" hangingPunct="0">
-              <a:lnSpc>
-                <a:spcPct val="250000"/>
-              </a:lnSpc>
-              <a:spcBef>
-                <a:spcPct val="0"/>
-              </a:spcBef>
-              <a:spcAft>
-                <a:spcPct val="0"/>
-              </a:spcAft>
-              <a:buClrTx/>
-              <a:buSzTx/>
-            </a:pPr>
-            <a:r>
-              <a:rPr kumimoji="0" lang="en-US" altLang="en-US" sz="1800" i="0" u="none" strike="noStrike" cap="none" normalizeH="0" baseline="0" dirty="0">
-                <a:ln>
-                  <a:noFill/>
-                </a:ln>
-                <a:solidFill>
-                  <a:schemeClr val="tx1"/>
-                </a:solidFill>
-                <a:effectLst/>
-                <a:latin typeface="Arial" panose="020B0604020202020204" pitchFamily="34" charset="0"/>
-              </a:rPr>
-              <a:t>Areas included students, freelancers, contractors and creative/collaborative work </a:t>
-            </a:r>
-          </a:p>
-          <a:p>
-            <a:pPr eaLnBrk="0" fontAlgn="base" hangingPunct="0">
-              <a:lnSpc>
-                <a:spcPct val="250000"/>
-              </a:lnSpc>
-              <a:spcBef>
-                <a:spcPct val="0"/>
-              </a:spcBef>
-              <a:spcAft>
-                <a:spcPct val="0"/>
-              </a:spcAft>
-              <a:buClrTx/>
-              <a:buSzTx/>
-            </a:pPr>
-            <a:r>
-              <a:rPr kumimoji="0" lang="en-US" altLang="en-US" sz="1800" i="0" u="none" strike="noStrike" cap="none" normalizeH="0" baseline="0" dirty="0">
-                <a:ln>
-                  <a:noFill/>
-                </a:ln>
-                <a:solidFill>
-                  <a:schemeClr val="tx1"/>
-                </a:solidFill>
-                <a:effectLst/>
-                <a:latin typeface="Arial" panose="020B0604020202020204" pitchFamily="34" charset="0"/>
-              </a:rPr>
-              <a:t>An interview was conducted with a small startup company </a:t>
-            </a:r>
-          </a:p>
-          <a:p>
-            <a:pPr eaLnBrk="0" fontAlgn="base" hangingPunct="0">
-              <a:lnSpc>
-                <a:spcPct val="250000"/>
-              </a:lnSpc>
-              <a:spcBef>
-                <a:spcPct val="0"/>
-              </a:spcBef>
-              <a:spcAft>
-                <a:spcPct val="0"/>
-              </a:spcAft>
-              <a:buClrTx/>
-              <a:buSzTx/>
-            </a:pPr>
-            <a:r>
-              <a:rPr kumimoji="0" lang="en-US" altLang="en-US" sz="1800" i="0" u="none" strike="noStrike" cap="none" normalizeH="0" baseline="0" dirty="0">
-                <a:ln>
-                  <a:noFill/>
-                </a:ln>
-                <a:solidFill>
-                  <a:schemeClr val="tx1"/>
-                </a:solidFill>
-                <a:effectLst/>
-                <a:latin typeface="Arial" panose="020B0604020202020204" pitchFamily="34" charset="0"/>
-              </a:rPr>
-              <a:t>Findings were compared with the comparative technology study </a:t>
-            </a:r>
-          </a:p>
-        </p:txBody>
-      </p:sp>
+      </p:pic>
     </p:spTree>
     <p:extLst>
       <p:ext uri="{BB962C8B-B14F-4D97-AF65-F5344CB8AC3E}">
-        <p14:creationId xmlns:p14="http://schemas.microsoft.com/office/powerpoint/2010/main" val="2126503624"/>
+        <p14:creationId xmlns:p14="http://schemas.microsoft.com/office/powerpoint/2010/main" val="2191069837"/>
       </p:ext>
     </p:extLst>
   </p:cSld>
@@ -5387,7 +5125,7 @@
           <p:cNvPr id="2" name="Title 1">
             <a:extLst>
               <a:ext uri="{FF2B5EF4-FFF2-40B4-BE49-F238E27FC236}">
-                <a16:creationId xmlns:a16="http://schemas.microsoft.com/office/drawing/2014/main" id="{D9516C51-1499-4C47-ABF8-E711269E191A}"/>
+                <a16:creationId xmlns:a16="http://schemas.microsoft.com/office/drawing/2014/main" id="{6E47D36C-9E4B-476F-AC15-C597C7C2A361}"/>
               </a:ext>
             </a:extLst>
           </p:cNvPr>
@@ -5405,7 +5143,7 @@
           <a:p>
             <a:r>
               <a:rPr lang="en-US" dirty="0"/>
-              <a:t>Elicitation Findings</a:t>
+              <a:t>Requirements Elicitation</a:t>
             </a:r>
           </a:p>
         </p:txBody>
@@ -5415,7 +5153,7 @@
           <p:cNvPr id="4" name="Rectangle 1">
             <a:extLst>
               <a:ext uri="{FF2B5EF4-FFF2-40B4-BE49-F238E27FC236}">
-                <a16:creationId xmlns:a16="http://schemas.microsoft.com/office/drawing/2014/main" id="{AB7E483C-F3C4-48B2-875B-D92D8F07B844}"/>
+                <a16:creationId xmlns:a16="http://schemas.microsoft.com/office/drawing/2014/main" id="{226A1D72-5045-437B-8F4B-DF9193C2CF49}"/>
               </a:ext>
             </a:extLst>
           </p:cNvPr>
@@ -5428,8 +5166,8 @@
         </p:nvSpPr>
         <p:spPr bwMode="auto">
           <a:xfrm>
-            <a:off x="1063752" y="2748484"/>
-            <a:ext cx="9576981" cy="2741776"/>
+            <a:off x="1069848" y="2775916"/>
+            <a:ext cx="8666475" cy="2741776"/>
           </a:xfrm>
           <a:prstGeom prst="rect">
             <a:avLst/>
@@ -5501,7 +5239,7 @@
                 <a:effectLst/>
                 <a:latin typeface="Arial" panose="020B0604020202020204" pitchFamily="34" charset="0"/>
               </a:rPr>
-              <a:t>Users need a personal workspace alongside collaborative project spaces </a:t>
+              <a:t>Survey focused on people involved in collaborative and individual work </a:t>
             </a:r>
           </a:p>
           <a:p>
@@ -5529,7 +5267,7 @@
                 <a:effectLst/>
                 <a:latin typeface="Arial" panose="020B0604020202020204" pitchFamily="34" charset="0"/>
               </a:rPr>
-              <a:t>Task management needs to include dependencies, deadlines and progress </a:t>
+              <a:t>Areas included students, freelancers, contractors and creative/collaborative work </a:t>
             </a:r>
           </a:p>
           <a:p>
@@ -5557,7 +5295,7 @@
                 <a:effectLst/>
                 <a:latin typeface="Arial" panose="020B0604020202020204" pitchFamily="34" charset="0"/>
               </a:rPr>
-              <a:t>Work hours and progress should be connected to the work being completed </a:t>
+              <a:t>An interview was conducted with a small startup company </a:t>
             </a:r>
           </a:p>
           <a:p>
@@ -5585,7 +5323,7 @@
                 <a:effectLst/>
                 <a:latin typeface="Arial" panose="020B0604020202020204" pitchFamily="34" charset="0"/>
               </a:rPr>
-              <a:t>Collaboration requires comments, shared workspaces, notifications and controlled access </a:t>
+              <a:t>Findings were compared with the comparative technology study </a:t>
             </a:r>
           </a:p>
         </p:txBody>
@@ -5593,7 +5331,7 @@
     </p:spTree>
     <p:extLst>
       <p:ext uri="{BB962C8B-B14F-4D97-AF65-F5344CB8AC3E}">
-        <p14:creationId xmlns:p14="http://schemas.microsoft.com/office/powerpoint/2010/main" val="2867110901"/>
+        <p14:creationId xmlns:p14="http://schemas.microsoft.com/office/powerpoint/2010/main" val="2126503624"/>
       </p:ext>
     </p:extLst>
   </p:cSld>
@@ -5625,7 +5363,7 @@
           <p:cNvPr id="2" name="Title 1">
             <a:extLst>
               <a:ext uri="{FF2B5EF4-FFF2-40B4-BE49-F238E27FC236}">
-                <a16:creationId xmlns:a16="http://schemas.microsoft.com/office/drawing/2014/main" id="{8596D026-14EB-4275-AA37-927D4B95C14E}"/>
+                <a16:creationId xmlns:a16="http://schemas.microsoft.com/office/drawing/2014/main" id="{D9516C51-1499-4C47-ABF8-E711269E191A}"/>
               </a:ext>
             </a:extLst>
           </p:cNvPr>
@@ -5643,73 +5381,187 @@
           <a:p>
             <a:r>
               <a:rPr lang="en-US" dirty="0"/>
-              <a:t>System Rquirements</a:t>
-            </a:r>
-          </a:p>
-        </p:txBody>
-      </p:sp>
-      <p:sp>
-        <p:nvSpPr>
-          <p:cNvPr id="3" name="Content Placeholder 2">
+              <a:t>Elicitation Findings</a:t>
+            </a:r>
+          </a:p>
+        </p:txBody>
+      </p:sp>
+      <p:sp>
+        <p:nvSpPr>
+          <p:cNvPr id="4" name="Rectangle 1">
             <a:extLst>
               <a:ext uri="{FF2B5EF4-FFF2-40B4-BE49-F238E27FC236}">
-                <a16:creationId xmlns:a16="http://schemas.microsoft.com/office/drawing/2014/main" id="{CF54B48D-8C8D-4738-8724-1A324E21127B}"/>
+                <a16:creationId xmlns:a16="http://schemas.microsoft.com/office/drawing/2014/main" id="{AB7E483C-F3C4-48B2-875B-D92D8F07B844}"/>
               </a:ext>
             </a:extLst>
           </p:cNvPr>
           <p:cNvSpPr>
-            <a:spLocks noGrp="1"/>
+            <a:spLocks noGrp="1" noChangeArrowheads="1"/>
           </p:cNvSpPr>
           <p:nvPr>
             <p:ph idx="1"/>
           </p:nvPr>
         </p:nvSpPr>
-        <p:spPr/>
-        <p:txBody>
-          <a:bodyPr/>
+        <p:spPr bwMode="auto">
+          <a:xfrm>
+            <a:off x="1063752" y="2748484"/>
+            <a:ext cx="9576981" cy="2741776"/>
+          </a:xfrm>
+          <a:prstGeom prst="rect">
+            <a:avLst/>
+          </a:prstGeom>
+          <a:noFill/>
+          <a:ln>
+            <a:noFill/>
+          </a:ln>
+          <a:effectLst/>
+          <a:extLst>
+            <a:ext uri="{909E8E84-426E-40DD-AFC4-6F175D3DCCD1}">
+              <a14:hiddenFill xmlns:a14="http://schemas.microsoft.com/office/drawing/2010/main">
+                <a:solidFill>
+                  <a:schemeClr val="accent1"/>
+                </a:solidFill>
+              </a14:hiddenFill>
+            </a:ext>
+            <a:ext uri="{91240B29-F687-4F45-9708-019B960494DF}">
+              <a14:hiddenLine xmlns:a14="http://schemas.microsoft.com/office/drawing/2010/main" w="9525">
+                <a:solidFill>
+                  <a:schemeClr val="tx1"/>
+                </a:solidFill>
+                <a:miter lim="800000"/>
+                <a:headEnd/>
+                <a:tailEnd/>
+              </a14:hiddenLine>
+            </a:ext>
+            <a:ext uri="{AF507438-7753-43E0-B8FC-AC1667EBCBE1}">
+              <a14:hiddenEffects xmlns:a14="http://schemas.microsoft.com/office/drawing/2010/main">
+                <a:effectLst>
+                  <a:outerShdw dist="35921" dir="2700000" algn="ctr" rotWithShape="0">
+                    <a:schemeClr val="bg2"/>
+                  </a:outerShdw>
+                </a:effectLst>
+              </a14:hiddenEffects>
+            </a:ext>
+          </a:extLst>
+        </p:spPr>
+        <p:txBody>
+          <a:bodyPr vert="horz" wrap="none" lIns="91440" tIns="45720" rIns="91440" bIns="45720" numCol="1" anchor="ctr" anchorCtr="0" compatLnSpc="1">
+            <a:prstTxWarp prst="textNoShape">
+              <a:avLst/>
+            </a:prstTxWarp>
+            <a:spAutoFit/>
+          </a:bodyPr>
           <a:lstStyle/>
           <a:p>
-            <a:pPr>
+            <a:pPr eaLnBrk="0" fontAlgn="base" hangingPunct="0">
               <a:lnSpc>
                 <a:spcPct val="250000"/>
               </a:lnSpc>
+              <a:spcBef>
+                <a:spcPct val="0"/>
+              </a:spcBef>
+              <a:spcAft>
+                <a:spcPct val="0"/>
+              </a:spcAft>
+              <a:buClrTx/>
+              <a:buSzTx/>
             </a:pPr>
             <a:r>
-              <a:rPr lang="en-US" dirty="0"/>
-              <a:t>Personal &amp; Task Management</a:t>
-            </a:r>
-          </a:p>
-          <a:p>
-            <a:pPr>
+              <a:rPr kumimoji="0" lang="en-US" altLang="en-US" sz="1800" i="0" u="none" strike="noStrike" cap="none" normalizeH="0" baseline="0" dirty="0">
+                <a:ln>
+                  <a:noFill/>
+                </a:ln>
+                <a:solidFill>
+                  <a:schemeClr val="tx1"/>
+                </a:solidFill>
+                <a:effectLst/>
+                <a:latin typeface="Arial" panose="020B0604020202020204" pitchFamily="34" charset="0"/>
+              </a:rPr>
+              <a:t>Users need a personal workspace alongside collaborative project spaces </a:t>
+            </a:r>
+          </a:p>
+          <a:p>
+            <a:pPr eaLnBrk="0" fontAlgn="base" hangingPunct="0">
               <a:lnSpc>
                 <a:spcPct val="250000"/>
               </a:lnSpc>
+              <a:spcBef>
+                <a:spcPct val="0"/>
+              </a:spcBef>
+              <a:spcAft>
+                <a:spcPct val="0"/>
+              </a:spcAft>
+              <a:buClrTx/>
+              <a:buSzTx/>
             </a:pPr>
             <a:r>
-              <a:rPr lang="en-US" dirty="0"/>
-              <a:t>Progress &amp; Work Hours</a:t>
-            </a:r>
-          </a:p>
-          <a:p>
-            <a:pPr>
+              <a:rPr kumimoji="0" lang="en-US" altLang="en-US" sz="1800" i="0" u="none" strike="noStrike" cap="none" normalizeH="0" baseline="0" dirty="0">
+                <a:ln>
+                  <a:noFill/>
+                </a:ln>
+                <a:solidFill>
+                  <a:schemeClr val="tx1"/>
+                </a:solidFill>
+                <a:effectLst/>
+                <a:latin typeface="Arial" panose="020B0604020202020204" pitchFamily="34" charset="0"/>
+              </a:rPr>
+              <a:t>Task management needs to include dependencies, deadlines and progress </a:t>
+            </a:r>
+          </a:p>
+          <a:p>
+            <a:pPr eaLnBrk="0" fontAlgn="base" hangingPunct="0">
               <a:lnSpc>
                 <a:spcPct val="250000"/>
               </a:lnSpc>
+              <a:spcBef>
+                <a:spcPct val="0"/>
+              </a:spcBef>
+              <a:spcAft>
+                <a:spcPct val="0"/>
+              </a:spcAft>
+              <a:buClrTx/>
+              <a:buSzTx/>
             </a:pPr>
             <a:r>
-              <a:rPr lang="en-US" dirty="0"/>
-              <a:t>Collaboration</a:t>
-            </a:r>
-          </a:p>
-          <a:p>
-            <a:pPr>
+              <a:rPr kumimoji="0" lang="en-US" altLang="en-US" sz="1800" i="0" u="none" strike="noStrike" cap="none" normalizeH="0" baseline="0" dirty="0">
+                <a:ln>
+                  <a:noFill/>
+                </a:ln>
+                <a:solidFill>
+                  <a:schemeClr val="tx1"/>
+                </a:solidFill>
+                <a:effectLst/>
+                <a:latin typeface="Arial" panose="020B0604020202020204" pitchFamily="34" charset="0"/>
+              </a:rPr>
+              <a:t>Work hours and progress should be connected to the work being completed </a:t>
+            </a:r>
+          </a:p>
+          <a:p>
+            <a:pPr eaLnBrk="0" fontAlgn="base" hangingPunct="0">
               <a:lnSpc>
                 <a:spcPct val="250000"/>
               </a:lnSpc>
+              <a:spcBef>
+                <a:spcPct val="0"/>
+              </a:spcBef>
+              <a:spcAft>
+                <a:spcPct val="0"/>
+              </a:spcAft>
+              <a:buClrTx/>
+              <a:buSzTx/>
             </a:pPr>
             <a:r>
-              <a:rPr lang="en-US" dirty="0"/>
-              <a:t>Access &amp; Evidence</a:t>
+              <a:rPr kumimoji="0" lang="en-US" altLang="en-US" sz="1800" i="0" u="none" strike="noStrike" cap="none" normalizeH="0" baseline="0" dirty="0">
+                <a:ln>
+                  <a:noFill/>
+                </a:ln>
+                <a:solidFill>
+                  <a:schemeClr val="tx1"/>
+                </a:solidFill>
+                <a:effectLst/>
+                <a:latin typeface="Arial" panose="020B0604020202020204" pitchFamily="34" charset="0"/>
+              </a:rPr>
+              <a:t>Collaboration requires comments, shared workspaces, notifications and controlled access </a:t>
             </a:r>
           </a:p>
         </p:txBody>
@@ -5717,7 +5569,7 @@
     </p:spTree>
     <p:extLst>
       <p:ext uri="{BB962C8B-B14F-4D97-AF65-F5344CB8AC3E}">
-        <p14:creationId xmlns:p14="http://schemas.microsoft.com/office/powerpoint/2010/main" val="3203471108"/>
+        <p14:creationId xmlns:p14="http://schemas.microsoft.com/office/powerpoint/2010/main" val="2867110901"/>
       </p:ext>
     </p:extLst>
   </p:cSld>
@@ -5749,7 +5601,7 @@
           <p:cNvPr id="2" name="Title 1">
             <a:extLst>
               <a:ext uri="{FF2B5EF4-FFF2-40B4-BE49-F238E27FC236}">
-                <a16:creationId xmlns:a16="http://schemas.microsoft.com/office/drawing/2014/main" id="{CD0762FE-5950-414B-9E2C-52AF699E716E}"/>
+                <a16:creationId xmlns:a16="http://schemas.microsoft.com/office/drawing/2014/main" id="{8596D026-14EB-4275-AA37-927D4B95C14E}"/>
               </a:ext>
             </a:extLst>
           </p:cNvPr>
@@ -5767,215 +5619,73 @@
           <a:p>
             <a:r>
               <a:rPr lang="en-US" dirty="0"/>
-              <a:t>Problem Domains</a:t>
-            </a:r>
-          </a:p>
-        </p:txBody>
-      </p:sp>
-      <p:sp>
-        <p:nvSpPr>
-          <p:cNvPr id="4" name="Rectangle 1">
+              <a:t>System Rquirements</a:t>
+            </a:r>
+          </a:p>
+        </p:txBody>
+      </p:sp>
+      <p:sp>
+        <p:nvSpPr>
+          <p:cNvPr id="3" name="Content Placeholder 2">
             <a:extLst>
               <a:ext uri="{FF2B5EF4-FFF2-40B4-BE49-F238E27FC236}">
-                <a16:creationId xmlns:a16="http://schemas.microsoft.com/office/drawing/2014/main" id="{C66EF7F6-C030-4711-A4B3-F9F755EDDA24}"/>
+                <a16:creationId xmlns:a16="http://schemas.microsoft.com/office/drawing/2014/main" id="{CF54B48D-8C8D-4738-8724-1A324E21127B}"/>
               </a:ext>
             </a:extLst>
           </p:cNvPr>
           <p:cNvSpPr>
-            <a:spLocks noGrp="1" noChangeArrowheads="1"/>
+            <a:spLocks noGrp="1"/>
           </p:cNvSpPr>
           <p:nvPr>
             <p:ph idx="1"/>
           </p:nvPr>
         </p:nvSpPr>
-        <p:spPr bwMode="auto">
-          <a:xfrm>
-            <a:off x="1069848" y="2449988"/>
-            <a:ext cx="4618700" cy="3434273"/>
-          </a:xfrm>
-          <a:prstGeom prst="rect">
-            <a:avLst/>
-          </a:prstGeom>
-          <a:noFill/>
-          <a:ln>
-            <a:noFill/>
-          </a:ln>
-          <a:effectLst/>
-          <a:extLst>
-            <a:ext uri="{909E8E84-426E-40DD-AFC4-6F175D3DCCD1}">
-              <a14:hiddenFill xmlns:a14="http://schemas.microsoft.com/office/drawing/2010/main">
-                <a:solidFill>
-                  <a:schemeClr val="accent1"/>
-                </a:solidFill>
-              </a14:hiddenFill>
-            </a:ext>
-            <a:ext uri="{91240B29-F687-4F45-9708-019B960494DF}">
-              <a14:hiddenLine xmlns:a14="http://schemas.microsoft.com/office/drawing/2010/main" w="9525">
-                <a:solidFill>
-                  <a:schemeClr val="tx1"/>
-                </a:solidFill>
-                <a:miter lim="800000"/>
-                <a:headEnd/>
-                <a:tailEnd/>
-              </a14:hiddenLine>
-            </a:ext>
-            <a:ext uri="{AF507438-7753-43E0-B8FC-AC1667EBCBE1}">
-              <a14:hiddenEffects xmlns:a14="http://schemas.microsoft.com/office/drawing/2010/main">
-                <a:effectLst>
-                  <a:outerShdw dist="35921" dir="2700000" algn="ctr" rotWithShape="0">
-                    <a:schemeClr val="bg2"/>
-                  </a:outerShdw>
-                </a:effectLst>
-              </a14:hiddenEffects>
-            </a:ext>
-          </a:extLst>
-        </p:spPr>
-        <p:txBody>
-          <a:bodyPr vert="horz" wrap="none" lIns="91440" tIns="45720" rIns="91440" bIns="45720" numCol="1" anchor="ctr" anchorCtr="0" compatLnSpc="1">
-            <a:prstTxWarp prst="textNoShape">
-              <a:avLst/>
-            </a:prstTxWarp>
-            <a:spAutoFit/>
-          </a:bodyPr>
+        <p:spPr/>
+        <p:txBody>
+          <a:bodyPr/>
           <a:lstStyle/>
           <a:p>
-            <a:pPr eaLnBrk="0" fontAlgn="base" hangingPunct="0">
+            <a:pPr>
               <a:lnSpc>
                 <a:spcPct val="250000"/>
               </a:lnSpc>
-              <a:spcBef>
-                <a:spcPct val="0"/>
-              </a:spcBef>
-              <a:spcAft>
-                <a:spcPct val="0"/>
-              </a:spcAft>
-              <a:buClrTx/>
-              <a:buSzTx/>
             </a:pPr>
             <a:r>
-              <a:rPr kumimoji="0" lang="en-US" altLang="en-US" sz="1800" i="0" u="none" strike="noStrike" cap="none" normalizeH="0" baseline="0" dirty="0">
-                <a:ln>
-                  <a:noFill/>
-                </a:ln>
-                <a:solidFill>
-                  <a:schemeClr val="tx1"/>
-                </a:solidFill>
-                <a:effectLst/>
-                <a:latin typeface="Arial" panose="020B0604020202020204" pitchFamily="34" charset="0"/>
-              </a:rPr>
-              <a:t>User Identity &amp; Access Management </a:t>
-            </a:r>
-          </a:p>
-          <a:p>
-            <a:pPr eaLnBrk="0" fontAlgn="base" hangingPunct="0">
+              <a:rPr lang="en-US" dirty="0"/>
+              <a:t>Personal &amp; Task Management</a:t>
+            </a:r>
+          </a:p>
+          <a:p>
+            <a:pPr>
               <a:lnSpc>
                 <a:spcPct val="250000"/>
               </a:lnSpc>
-              <a:spcBef>
-                <a:spcPct val="0"/>
-              </a:spcBef>
-              <a:spcAft>
-                <a:spcPct val="0"/>
-              </a:spcAft>
-              <a:buClrTx/>
-              <a:buSzTx/>
             </a:pPr>
             <a:r>
-              <a:rPr kumimoji="0" lang="en-US" altLang="en-US" sz="1800" i="0" u="none" strike="noStrike" cap="none" normalizeH="0" baseline="0" dirty="0">
-                <a:ln>
-                  <a:noFill/>
-                </a:ln>
-                <a:solidFill>
-                  <a:schemeClr val="tx1"/>
-                </a:solidFill>
-                <a:effectLst/>
-                <a:latin typeface="Arial" panose="020B0604020202020204" pitchFamily="34" charset="0"/>
-              </a:rPr>
-              <a:t>Task Lifecycle &amp; Context Aggregation </a:t>
-            </a:r>
-          </a:p>
-          <a:p>
-            <a:pPr eaLnBrk="0" fontAlgn="base" hangingPunct="0">
+              <a:rPr lang="en-US" dirty="0"/>
+              <a:t>Progress &amp; Work Hours</a:t>
+            </a:r>
+          </a:p>
+          <a:p>
+            <a:pPr>
               <a:lnSpc>
                 <a:spcPct val="250000"/>
               </a:lnSpc>
-              <a:spcBef>
-                <a:spcPct val="0"/>
-              </a:spcBef>
-              <a:spcAft>
-                <a:spcPct val="0"/>
-              </a:spcAft>
-              <a:buClrTx/>
-              <a:buSzTx/>
             </a:pPr>
             <a:r>
-              <a:rPr kumimoji="0" lang="en-US" altLang="en-US" sz="1800" i="0" u="none" strike="noStrike" cap="none" normalizeH="0" baseline="0" dirty="0">
-                <a:ln>
-                  <a:noFill/>
-                </a:ln>
-                <a:solidFill>
-                  <a:schemeClr val="tx1"/>
-                </a:solidFill>
-                <a:effectLst/>
-                <a:latin typeface="Arial" panose="020B0604020202020204" pitchFamily="34" charset="0"/>
-              </a:rPr>
-              <a:t>Dependency &amp; Dynamic Timeline Engine </a:t>
-            </a:r>
-          </a:p>
-          <a:p>
-            <a:pPr eaLnBrk="0" fontAlgn="base" hangingPunct="0">
+              <a:rPr lang="en-US" dirty="0"/>
+              <a:t>Collaboration</a:t>
+            </a:r>
+          </a:p>
+          <a:p>
+            <a:pPr>
               <a:lnSpc>
                 <a:spcPct val="250000"/>
               </a:lnSpc>
-              <a:spcBef>
-                <a:spcPct val="0"/>
-              </a:spcBef>
-              <a:spcAft>
-                <a:spcPct val="0"/>
-              </a:spcAft>
-              <a:buClrTx/>
-              <a:buSzTx/>
             </a:pPr>
             <a:r>
-              <a:rPr kumimoji="0" lang="en-US" altLang="en-US" sz="1800" i="0" u="none" strike="noStrike" cap="none" normalizeH="0" baseline="0" dirty="0">
-                <a:ln>
-                  <a:noFill/>
-                </a:ln>
-                <a:solidFill>
-                  <a:schemeClr val="tx1"/>
-                </a:solidFill>
-                <a:effectLst/>
-                <a:latin typeface="Arial" panose="020B0604020202020204" pitchFamily="34" charset="0"/>
-              </a:rPr>
-              <a:t>Workload Capacity &amp; SLA Effort Tracking </a:t>
-            </a:r>
-          </a:p>
-          <a:p>
-            <a:pPr eaLnBrk="0" fontAlgn="base" hangingPunct="0">
-              <a:lnSpc>
-                <a:spcPct val="250000"/>
-              </a:lnSpc>
-              <a:spcBef>
-                <a:spcPct val="0"/>
-              </a:spcBef>
-              <a:spcAft>
-                <a:spcPct val="0"/>
-              </a:spcAft>
-              <a:buClrTx/>
-              <a:buSzTx/>
-            </a:pPr>
-            <a:r>
-              <a:rPr kumimoji="0" lang="en-US" altLang="en-US" sz="1800" i="0" u="none" strike="noStrike" cap="none" normalizeH="0" baseline="0" dirty="0">
-                <a:ln>
-                  <a:noFill/>
-                </a:ln>
-                <a:solidFill>
-                  <a:schemeClr val="tx1"/>
-                </a:solidFill>
-                <a:effectLst/>
-                <a:latin typeface="Arial" panose="020B0604020202020204" pitchFamily="34" charset="0"/>
-              </a:rPr>
-              <a:t>Analytics &amp; Performance Metrics Engine </a:t>
+              <a:rPr lang="en-US" dirty="0"/>
+              <a:t>Access &amp; Evidence</a:t>
             </a:r>
           </a:p>
         </p:txBody>
@@ -5983,7 +5693,7 @@
     </p:spTree>
     <p:extLst>
       <p:ext uri="{BB962C8B-B14F-4D97-AF65-F5344CB8AC3E}">
-        <p14:creationId xmlns:p14="http://schemas.microsoft.com/office/powerpoint/2010/main" val="2917343981"/>
+        <p14:creationId xmlns:p14="http://schemas.microsoft.com/office/powerpoint/2010/main" val="3203471108"/>
       </p:ext>
     </p:extLst>
   </p:cSld>
@@ -6015,7 +5725,7 @@
           <p:cNvPr id="2" name="Title 1">
             <a:extLst>
               <a:ext uri="{FF2B5EF4-FFF2-40B4-BE49-F238E27FC236}">
-                <a16:creationId xmlns:a16="http://schemas.microsoft.com/office/drawing/2014/main" id="{BDE9BB4B-D983-4001-BC34-A47995468D0E}"/>
+                <a16:creationId xmlns:a16="http://schemas.microsoft.com/office/drawing/2014/main" id="{CD0762FE-5950-414B-9E2C-52AF699E716E}"/>
               </a:ext>
             </a:extLst>
           </p:cNvPr>
@@ -6033,7 +5743,7 @@
           <a:p>
             <a:r>
               <a:rPr lang="en-US" dirty="0"/>
-              <a:t>System Design</a:t>
+              <a:t>Problem Domains</a:t>
             </a:r>
           </a:p>
         </p:txBody>
@@ -6043,7 +5753,7 @@
           <p:cNvPr id="4" name="Rectangle 1">
             <a:extLst>
               <a:ext uri="{FF2B5EF4-FFF2-40B4-BE49-F238E27FC236}">
-                <a16:creationId xmlns:a16="http://schemas.microsoft.com/office/drawing/2014/main" id="{ADC51022-6E16-4E6B-A3BB-5744DA5C70E7}"/>
+                <a16:creationId xmlns:a16="http://schemas.microsoft.com/office/drawing/2014/main" id="{C66EF7F6-C030-4711-A4B3-F9F755EDDA24}"/>
               </a:ext>
             </a:extLst>
           </p:cNvPr>
@@ -6056,8 +5766,8 @@
         </p:nvSpPr>
         <p:spPr bwMode="auto">
           <a:xfrm>
-            <a:off x="1066800" y="2748483"/>
-            <a:ext cx="9979335" cy="2741776"/>
+            <a:off x="1069848" y="2449988"/>
+            <a:ext cx="4618700" cy="3434273"/>
           </a:xfrm>
           <a:prstGeom prst="rect">
             <a:avLst/>
@@ -6129,7 +5839,7 @@
                 <a:effectLst/>
                 <a:latin typeface="Arial" panose="020B0604020202020204" pitchFamily="34" charset="0"/>
               </a:rPr>
-              <a:t>Design translates the identified requirements and domains into an implementable structure </a:t>
+              <a:t>User Identity &amp; Access Management </a:t>
             </a:r>
           </a:p>
           <a:p>
@@ -6157,7 +5867,7 @@
                 <a:effectLst/>
                 <a:latin typeface="Arial" panose="020B0604020202020204" pitchFamily="34" charset="0"/>
               </a:rPr>
-              <a:t>Backend responsibilities are separated into distinct business domains </a:t>
+              <a:t>Task Lifecycle &amp; Context Aggregation </a:t>
             </a:r>
           </a:p>
           <a:p>
@@ -6185,7 +5895,7 @@
                 <a:effectLst/>
                 <a:latin typeface="Arial" panose="020B0604020202020204" pitchFamily="34" charset="0"/>
               </a:rPr>
-              <a:t>Database design connects users, tasks, projects, dependencies, work logs and analytics </a:t>
+              <a:t>Dependency &amp; Dynamic Timeline Engine </a:t>
             </a:r>
           </a:p>
           <a:p>
@@ -6213,8 +5923,322 @@
                 <a:effectLst/>
                 <a:latin typeface="Arial" panose="020B0604020202020204" pitchFamily="34" charset="0"/>
               </a:rPr>
-              <a:t>Interface and navigation design provide access to these functions through the user's workflow </a:t>
-            </a:r>
+              <a:t>Workload Capacity &amp; SLA Effort Tracking </a:t>
+            </a:r>
+          </a:p>
+          <a:p>
+            <a:pPr eaLnBrk="0" fontAlgn="base" hangingPunct="0">
+              <a:lnSpc>
+                <a:spcPct val="250000"/>
+              </a:lnSpc>
+              <a:spcBef>
+                <a:spcPct val="0"/>
+              </a:spcBef>
+              <a:spcAft>
+                <a:spcPct val="0"/>
+              </a:spcAft>
+              <a:buClrTx/>
+              <a:buSzTx/>
+            </a:pPr>
+            <a:r>
+              <a:rPr kumimoji="0" lang="en-US" altLang="en-US" sz="1800" i="0" u="none" strike="noStrike" cap="none" normalizeH="0" baseline="0" dirty="0">
+                <a:ln>
+                  <a:noFill/>
+                </a:ln>
+                <a:solidFill>
+                  <a:schemeClr val="tx1"/>
+                </a:solidFill>
+                <a:effectLst/>
+                <a:latin typeface="Arial" panose="020B0604020202020204" pitchFamily="34" charset="0"/>
+              </a:rPr>
+              <a:t>Analytics &amp; Performance Metrics Engine </a:t>
+            </a:r>
+          </a:p>
+        </p:txBody>
+      </p:sp>
+    </p:spTree>
+    <p:extLst>
+      <p:ext uri="{BB962C8B-B14F-4D97-AF65-F5344CB8AC3E}">
+        <p14:creationId xmlns:p14="http://schemas.microsoft.com/office/powerpoint/2010/main" val="2917343981"/>
+      </p:ext>
+    </p:extLst>
+  </p:cSld>
+  <p:clrMapOvr>
+    <a:masterClrMapping/>
+  </p:clrMapOvr>
+</p:sld>
+</file>
+
+<file path=ppt/slides/slide18.xml><?xml version="1.0" encoding="utf-8"?>
+<p:sld xmlns:a="http://schemas.openxmlformats.org/drawingml/2006/main" xmlns:r="http://schemas.openxmlformats.org/officeDocument/2006/relationships" xmlns:p="http://schemas.openxmlformats.org/presentationml/2006/main">
+  <p:cSld>
+    <p:spTree>
+      <p:nvGrpSpPr>
+        <p:cNvPr id="1" name=""/>
+        <p:cNvGrpSpPr/>
+        <p:nvPr/>
+      </p:nvGrpSpPr>
+      <p:grpSpPr>
+        <a:xfrm>
+          <a:off x="0" y="0"/>
+          <a:ext cx="0" cy="0"/>
+          <a:chOff x="0" y="0"/>
+          <a:chExt cx="0" cy="0"/>
+        </a:xfrm>
+      </p:grpSpPr>
+      <p:sp>
+        <p:nvSpPr>
+          <p:cNvPr id="2" name="Title 1">
+            <a:extLst>
+              <a:ext uri="{FF2B5EF4-FFF2-40B4-BE49-F238E27FC236}">
+                <a16:creationId xmlns:a16="http://schemas.microsoft.com/office/drawing/2014/main" id="{BDE9BB4B-D983-4001-BC34-A47995468D0E}"/>
+              </a:ext>
+            </a:extLst>
+          </p:cNvPr>
+          <p:cNvSpPr>
+            <a:spLocks noGrp="1"/>
+          </p:cNvSpPr>
+          <p:nvPr>
+            <p:ph type="title"/>
+          </p:nvPr>
+        </p:nvSpPr>
+        <p:spPr/>
+        <p:txBody>
+          <a:bodyPr/>
+          <a:lstStyle/>
+          <a:p>
+            <a:r>
+              <a:rPr lang="en-US" dirty="0"/>
+              <a:t>System Design</a:t>
+            </a:r>
+          </a:p>
+        </p:txBody>
+      </p:sp>
+      <p:sp>
+        <p:nvSpPr>
+          <p:cNvPr id="4" name="Rectangle 1">
+            <a:extLst>
+              <a:ext uri="{FF2B5EF4-FFF2-40B4-BE49-F238E27FC236}">
+                <a16:creationId xmlns:a16="http://schemas.microsoft.com/office/drawing/2014/main" id="{ADC51022-6E16-4E6B-A3BB-5744DA5C70E7}"/>
+              </a:ext>
+            </a:extLst>
+          </p:cNvPr>
+          <p:cNvSpPr>
+            <a:spLocks noGrp="1" noChangeArrowheads="1"/>
+          </p:cNvSpPr>
+          <p:nvPr>
+            <p:ph idx="1"/>
+          </p:nvPr>
+        </p:nvSpPr>
+        <p:spPr bwMode="auto">
+          <a:xfrm>
+            <a:off x="1063752" y="1750335"/>
+            <a:ext cx="10058400" cy="3357329"/>
+          </a:xfrm>
+          <a:prstGeom prst="rect">
+            <a:avLst/>
+          </a:prstGeom>
+          <a:noFill/>
+          <a:ln>
+            <a:noFill/>
+          </a:ln>
+          <a:effectLst/>
+          <a:extLst>
+            <a:ext uri="{909E8E84-426E-40DD-AFC4-6F175D3DCCD1}">
+              <a14:hiddenFill xmlns:a14="http://schemas.microsoft.com/office/drawing/2010/main">
+                <a:solidFill>
+                  <a:schemeClr val="accent1"/>
+                </a:solidFill>
+              </a14:hiddenFill>
+            </a:ext>
+            <a:ext uri="{91240B29-F687-4F45-9708-019B960494DF}">
+              <a14:hiddenLine xmlns:a14="http://schemas.microsoft.com/office/drawing/2010/main" w="9525">
+                <a:solidFill>
+                  <a:schemeClr val="tx1"/>
+                </a:solidFill>
+                <a:miter lim="800000"/>
+                <a:headEnd/>
+                <a:tailEnd/>
+              </a14:hiddenLine>
+            </a:ext>
+            <a:ext uri="{AF507438-7753-43E0-B8FC-AC1667EBCBE1}">
+              <a14:hiddenEffects xmlns:a14="http://schemas.microsoft.com/office/drawing/2010/main">
+                <a:effectLst>
+                  <a:outerShdw dist="35921" dir="2700000" algn="ctr" rotWithShape="0">
+                    <a:schemeClr val="bg2"/>
+                  </a:outerShdw>
+                </a:effectLst>
+              </a14:hiddenEffects>
+            </a:ext>
+          </a:extLst>
+        </p:spPr>
+        <p:txBody>
+          <a:bodyPr vert="horz" wrap="square" lIns="91440" tIns="45720" rIns="91440" bIns="45720" numCol="1" anchor="ctr" anchorCtr="0" compatLnSpc="1">
+            <a:prstTxWarp prst="textNoShape">
+              <a:avLst/>
+            </a:prstTxWarp>
+            <a:spAutoFit/>
+          </a:bodyPr>
+          <a:lstStyle/>
+          <a:p>
+            <a:pPr marL="2271400" lvl="8" indent="0" eaLnBrk="0" fontAlgn="base" hangingPunct="0">
+              <a:lnSpc>
+                <a:spcPct val="250000"/>
+              </a:lnSpc>
+              <a:spcBef>
+                <a:spcPct val="0"/>
+              </a:spcBef>
+              <a:spcAft>
+                <a:spcPct val="0"/>
+              </a:spcAft>
+              <a:buClrTx/>
+              <a:buSzTx/>
+              <a:buNone/>
+            </a:pPr>
+            <a:r>
+              <a:rPr kumimoji="0" lang="en-US" altLang="en-US" sz="1400" i="0" u="none" strike="noStrike" cap="none" normalizeH="0" baseline="0" dirty="0">
+                <a:ln>
+                  <a:noFill/>
+                </a:ln>
+                <a:solidFill>
+                  <a:schemeClr val="tx1"/>
+                </a:solidFill>
+                <a:effectLst/>
+                <a:latin typeface="Arial" panose="020B0604020202020204" pitchFamily="34" charset="0"/>
+              </a:rPr>
+              <a:t>		          </a:t>
+            </a:r>
+            <a:r>
+              <a:rPr kumimoji="0" lang="en-US" altLang="en-US" b="1" i="1" u="none" strike="noStrike" cap="none" normalizeH="0" baseline="0" dirty="0">
+                <a:ln>
+                  <a:noFill/>
+                </a:ln>
+                <a:solidFill>
+                  <a:schemeClr val="tx1"/>
+                </a:solidFill>
+                <a:effectLst/>
+                <a:latin typeface="Arial" panose="020B0604020202020204" pitchFamily="34" charset="0"/>
+              </a:rPr>
+              <a:t>Table of Diagrams:</a:t>
+            </a:r>
+            <a:endParaRPr kumimoji="0" lang="en-US" altLang="en-US" sz="1400" b="1" i="1" u="none" strike="noStrike" cap="none" normalizeH="0" baseline="0" dirty="0">
+              <a:ln>
+                <a:noFill/>
+              </a:ln>
+              <a:solidFill>
+                <a:schemeClr val="tx1"/>
+              </a:solidFill>
+              <a:effectLst/>
+              <a:latin typeface="Arial" panose="020B0604020202020204" pitchFamily="34" charset="0"/>
+            </a:endParaRPr>
+          </a:p>
+          <a:p>
+            <a:pPr eaLnBrk="0" fontAlgn="base" hangingPunct="0">
+              <a:lnSpc>
+                <a:spcPct val="250000"/>
+              </a:lnSpc>
+              <a:spcBef>
+                <a:spcPct val="0"/>
+              </a:spcBef>
+              <a:spcAft>
+                <a:spcPct val="0"/>
+              </a:spcAft>
+              <a:buClrTx/>
+              <a:buSzTx/>
+            </a:pPr>
+            <a:r>
+              <a:rPr kumimoji="0" lang="en-US" altLang="en-US" sz="1800" i="0" u="none" strike="noStrike" cap="none" normalizeH="0" baseline="0" dirty="0">
+                <a:ln>
+                  <a:noFill/>
+                </a:ln>
+                <a:solidFill>
+                  <a:schemeClr val="tx1"/>
+                </a:solidFill>
+                <a:effectLst/>
+                <a:latin typeface="Arial" panose="020B0604020202020204" pitchFamily="34" charset="0"/>
+              </a:rPr>
+              <a:t>System Architecture Diagram</a:t>
+            </a:r>
+          </a:p>
+          <a:p>
+            <a:pPr eaLnBrk="0" fontAlgn="base" hangingPunct="0">
+              <a:lnSpc>
+                <a:spcPct val="250000"/>
+              </a:lnSpc>
+              <a:spcBef>
+                <a:spcPct val="0"/>
+              </a:spcBef>
+              <a:spcAft>
+                <a:spcPct val="0"/>
+              </a:spcAft>
+              <a:buClrTx/>
+              <a:buSzTx/>
+            </a:pPr>
+            <a:r>
+              <a:rPr lang="en-US" altLang="en-US" sz="1800" dirty="0">
+                <a:latin typeface="Arial" panose="020B0604020202020204" pitchFamily="34" charset="0"/>
+              </a:rPr>
+              <a:t>Entity Relation Diagram</a:t>
+            </a:r>
+          </a:p>
+          <a:p>
+            <a:pPr eaLnBrk="0" fontAlgn="base" hangingPunct="0">
+              <a:lnSpc>
+                <a:spcPct val="250000"/>
+              </a:lnSpc>
+              <a:spcBef>
+                <a:spcPct val="0"/>
+              </a:spcBef>
+              <a:spcAft>
+                <a:spcPct val="0"/>
+              </a:spcAft>
+              <a:buClrTx/>
+              <a:buSzTx/>
+            </a:pPr>
+            <a:r>
+              <a:rPr kumimoji="0" lang="en-US" altLang="en-US" sz="1800" i="0" u="none" strike="noStrike" cap="none" normalizeH="0" baseline="0" dirty="0">
+                <a:ln>
+                  <a:noFill/>
+                </a:ln>
+                <a:solidFill>
+                  <a:schemeClr val="tx1"/>
+                </a:solidFill>
+                <a:effectLst/>
+                <a:latin typeface="Arial" panose="020B0604020202020204" pitchFamily="34" charset="0"/>
+              </a:rPr>
+              <a:t>Activity Diagram</a:t>
+            </a:r>
+          </a:p>
+          <a:p>
+            <a:pPr eaLnBrk="0" fontAlgn="base" hangingPunct="0">
+              <a:lnSpc>
+                <a:spcPct val="250000"/>
+              </a:lnSpc>
+              <a:spcBef>
+                <a:spcPct val="0"/>
+              </a:spcBef>
+              <a:spcAft>
+                <a:spcPct val="0"/>
+              </a:spcAft>
+              <a:buClrTx/>
+              <a:buSzTx/>
+            </a:pPr>
+            <a:r>
+              <a:rPr lang="en-US" altLang="en-US" sz="1800" dirty="0">
+                <a:latin typeface="Arial" panose="020B0604020202020204" pitchFamily="34" charset="0"/>
+              </a:rPr>
+              <a:t>Use Case Diagram</a:t>
+            </a:r>
+            <a:endParaRPr kumimoji="0" lang="en-US" altLang="en-US" sz="1800" i="0" u="none" strike="noStrike" cap="none" normalizeH="0" baseline="0" dirty="0">
+              <a:ln>
+                <a:noFill/>
+              </a:ln>
+              <a:solidFill>
+                <a:schemeClr val="tx1"/>
+              </a:solidFill>
+              <a:effectLst/>
+              <a:latin typeface="Arial" panose="020B0604020202020204" pitchFamily="34" charset="0"/>
+            </a:endParaRPr>
           </a:p>
         </p:txBody>
       </p:sp>
@@ -6231,7 +6255,7 @@
 </p:sld>
 </file>
 
-<file path=ppt/slides/slide18.xml><?xml version="1.0" encoding="utf-8"?>
+<file path=ppt/slides/slide19.xml><?xml version="1.0" encoding="utf-8"?>
 <p:sld xmlns:a="http://schemas.openxmlformats.org/drawingml/2006/main" xmlns:r="http://schemas.openxmlformats.org/officeDocument/2006/relationships" xmlns:p="http://schemas.openxmlformats.org/presentationml/2006/main">
   <p:cSld>
     <p:spTree>
@@ -6324,99 +6348,6 @@
 </p:sld>
 </file>
 
-<file path=ppt/slides/slide19.xml><?xml version="1.0" encoding="utf-8"?>
-<p:sld xmlns:a="http://schemas.openxmlformats.org/drawingml/2006/main" xmlns:r="http://schemas.openxmlformats.org/officeDocument/2006/relationships" xmlns:p="http://schemas.openxmlformats.org/presentationml/2006/main">
-  <p:cSld>
-    <p:spTree>
-      <p:nvGrpSpPr>
-        <p:cNvPr id="1" name=""/>
-        <p:cNvGrpSpPr/>
-        <p:nvPr/>
-      </p:nvGrpSpPr>
-      <p:grpSpPr>
-        <a:xfrm>
-          <a:off x="0" y="0"/>
-          <a:ext cx="0" cy="0"/>
-          <a:chOff x="0" y="0"/>
-          <a:chExt cx="0" cy="0"/>
-        </a:xfrm>
-      </p:grpSpPr>
-      <p:sp>
-        <p:nvSpPr>
-          <p:cNvPr id="2" name="Title 1">
-            <a:extLst>
-              <a:ext uri="{FF2B5EF4-FFF2-40B4-BE49-F238E27FC236}">
-                <a16:creationId xmlns:a16="http://schemas.microsoft.com/office/drawing/2014/main" id="{BEEFE563-F49D-4383-BC03-D03DEAD6AD74}"/>
-              </a:ext>
-            </a:extLst>
-          </p:cNvPr>
-          <p:cNvSpPr>
-            <a:spLocks noGrp="1"/>
-          </p:cNvSpPr>
-          <p:nvPr>
-            <p:ph type="title"/>
-          </p:nvPr>
-        </p:nvSpPr>
-        <p:spPr/>
-        <p:txBody>
-          <a:bodyPr/>
-          <a:lstStyle/>
-          <a:p>
-            <a:r>
-              <a:rPr lang="en-US" dirty="0"/>
-              <a:t>Entity Relation Diagram</a:t>
-            </a:r>
-          </a:p>
-        </p:txBody>
-      </p:sp>
-      <p:pic>
-        <p:nvPicPr>
-          <p:cNvPr id="6" name="Content Placeholder 5">
-            <a:extLst>
-              <a:ext uri="{FF2B5EF4-FFF2-40B4-BE49-F238E27FC236}">
-                <a16:creationId xmlns:a16="http://schemas.microsoft.com/office/drawing/2014/main" id="{30EC794F-7E00-4C39-BCD2-26ECF34B94EB}"/>
-              </a:ext>
-            </a:extLst>
-          </p:cNvPr>
-          <p:cNvPicPr>
-            <a:picLocks noGrp="1" noChangeAspect="1"/>
-          </p:cNvPicPr>
-          <p:nvPr>
-            <p:ph idx="1"/>
-          </p:nvPr>
-        </p:nvPicPr>
-        <p:blipFill>
-          <a:blip r:embed="rId2">
-            <a:extLst>
-              <a:ext uri="{28A0092B-C50C-407E-A947-70E740481C1C}">
-                <a14:useLocalDpi xmlns:a14="http://schemas.microsoft.com/office/drawing/2010/main" val="0"/>
-              </a:ext>
-            </a:extLst>
-          </a:blip>
-          <a:stretch>
-            <a:fillRect/>
-          </a:stretch>
-        </p:blipFill>
-        <p:spPr>
-          <a:xfrm>
-            <a:off x="2076500" y="685800"/>
-            <a:ext cx="4235350" cy="5019675"/>
-          </a:xfrm>
-        </p:spPr>
-      </p:pic>
-    </p:spTree>
-    <p:extLst>
-      <p:ext uri="{BB962C8B-B14F-4D97-AF65-F5344CB8AC3E}">
-        <p14:creationId xmlns:p14="http://schemas.microsoft.com/office/powerpoint/2010/main" val="3930188597"/>
-      </p:ext>
-    </p:extLst>
-  </p:cSld>
-  <p:clrMapOvr>
-    <a:masterClrMapping/>
-  </p:clrMapOvr>
-</p:sld>
-</file>
-
 <file path=ppt/slides/slide2.xml><?xml version="1.0" encoding="utf-8"?>
 <p:sld xmlns:a="http://schemas.openxmlformats.org/drawingml/2006/main" xmlns:r="http://schemas.openxmlformats.org/officeDocument/2006/relationships" xmlns:p="http://schemas.openxmlformats.org/presentationml/2006/main">
   <p:cSld>
@@ -6727,6 +6658,99 @@
 </file>
 
 <file path=ppt/slides/slide20.xml><?xml version="1.0" encoding="utf-8"?>
+<p:sld xmlns:a="http://schemas.openxmlformats.org/drawingml/2006/main" xmlns:r="http://schemas.openxmlformats.org/officeDocument/2006/relationships" xmlns:p="http://schemas.openxmlformats.org/presentationml/2006/main">
+  <p:cSld>
+    <p:spTree>
+      <p:nvGrpSpPr>
+        <p:cNvPr id="1" name=""/>
+        <p:cNvGrpSpPr/>
+        <p:nvPr/>
+      </p:nvGrpSpPr>
+      <p:grpSpPr>
+        <a:xfrm>
+          <a:off x="0" y="0"/>
+          <a:ext cx="0" cy="0"/>
+          <a:chOff x="0" y="0"/>
+          <a:chExt cx="0" cy="0"/>
+        </a:xfrm>
+      </p:grpSpPr>
+      <p:sp>
+        <p:nvSpPr>
+          <p:cNvPr id="2" name="Title 1">
+            <a:extLst>
+              <a:ext uri="{FF2B5EF4-FFF2-40B4-BE49-F238E27FC236}">
+                <a16:creationId xmlns:a16="http://schemas.microsoft.com/office/drawing/2014/main" id="{BEEFE563-F49D-4383-BC03-D03DEAD6AD74}"/>
+              </a:ext>
+            </a:extLst>
+          </p:cNvPr>
+          <p:cNvSpPr>
+            <a:spLocks noGrp="1"/>
+          </p:cNvSpPr>
+          <p:nvPr>
+            <p:ph type="title"/>
+          </p:nvPr>
+        </p:nvSpPr>
+        <p:spPr/>
+        <p:txBody>
+          <a:bodyPr/>
+          <a:lstStyle/>
+          <a:p>
+            <a:r>
+              <a:rPr lang="en-US" dirty="0"/>
+              <a:t>Entity Relation Diagram</a:t>
+            </a:r>
+          </a:p>
+        </p:txBody>
+      </p:sp>
+      <p:pic>
+        <p:nvPicPr>
+          <p:cNvPr id="8" name="Content Placeholder 7">
+            <a:extLst>
+              <a:ext uri="{FF2B5EF4-FFF2-40B4-BE49-F238E27FC236}">
+                <a16:creationId xmlns:a16="http://schemas.microsoft.com/office/drawing/2014/main" id="{59322A46-749E-489B-8891-33C283C40685}"/>
+              </a:ext>
+            </a:extLst>
+          </p:cNvPr>
+          <p:cNvPicPr>
+            <a:picLocks noGrp="1" noChangeAspect="1"/>
+          </p:cNvPicPr>
+          <p:nvPr>
+            <p:ph idx="1"/>
+          </p:nvPr>
+        </p:nvPicPr>
+        <p:blipFill>
+          <a:blip r:embed="rId2">
+            <a:extLst>
+              <a:ext uri="{28A0092B-C50C-407E-A947-70E740481C1C}">
+                <a14:useLocalDpi xmlns:a14="http://schemas.microsoft.com/office/drawing/2010/main" val="0"/>
+              </a:ext>
+            </a:extLst>
+          </a:blip>
+          <a:stretch>
+            <a:fillRect/>
+          </a:stretch>
+        </p:blipFill>
+        <p:spPr>
+          <a:xfrm>
+            <a:off x="1618873" y="505291"/>
+            <a:ext cx="5215063" cy="5847418"/>
+          </a:xfrm>
+        </p:spPr>
+      </p:pic>
+    </p:spTree>
+    <p:extLst>
+      <p:ext uri="{BB962C8B-B14F-4D97-AF65-F5344CB8AC3E}">
+        <p14:creationId xmlns:p14="http://schemas.microsoft.com/office/powerpoint/2010/main" val="3930188597"/>
+      </p:ext>
+    </p:extLst>
+  </p:cSld>
+  <p:clrMapOvr>
+    <a:masterClrMapping/>
+  </p:clrMapOvr>
+</p:sld>
+</file>
+
+<file path=ppt/slides/slide21.xml><?xml version="1.0" encoding="utf-8"?>
 <p:sld xmlns:a="http://schemas.openxmlformats.org/drawingml/2006/main" xmlns:r="http://schemas.openxmlformats.org/officeDocument/2006/relationships" xmlns:p="http://schemas.openxmlformats.org/presentationml/2006/main">
   <p:cSld>
     <p:spTree>
@@ -6819,7 +6843,7 @@
 </p:sld>
 </file>
 
-<file path=ppt/slides/slide21.xml><?xml version="1.0" encoding="utf-8"?>
+<file path=ppt/slides/slide22.xml><?xml version="1.0" encoding="utf-8"?>
 <p:sld xmlns:a="http://schemas.openxmlformats.org/drawingml/2006/main" xmlns:r="http://schemas.openxmlformats.org/officeDocument/2006/relationships" xmlns:p="http://schemas.openxmlformats.org/presentationml/2006/main">
   <p:cSld>
     <p:spTree>
@@ -6912,436 +6936,6 @@
 </p:sld>
 </file>
 
-<file path=ppt/slides/slide22.xml><?xml version="1.0" encoding="utf-8"?>
-<p:sld xmlns:a="http://schemas.openxmlformats.org/drawingml/2006/main" xmlns:r="http://schemas.openxmlformats.org/officeDocument/2006/relationships" xmlns:p="http://schemas.openxmlformats.org/presentationml/2006/main">
-  <p:cSld>
-    <p:spTree>
-      <p:nvGrpSpPr>
-        <p:cNvPr id="1" name=""/>
-        <p:cNvGrpSpPr/>
-        <p:nvPr/>
-      </p:nvGrpSpPr>
-      <p:grpSpPr>
-        <a:xfrm>
-          <a:off x="0" y="0"/>
-          <a:ext cx="0" cy="0"/>
-          <a:chOff x="0" y="0"/>
-          <a:chExt cx="0" cy="0"/>
-        </a:xfrm>
-      </p:grpSpPr>
-      <p:sp>
-        <p:nvSpPr>
-          <p:cNvPr id="2" name="Title 1">
-            <a:extLst>
-              <a:ext uri="{FF2B5EF4-FFF2-40B4-BE49-F238E27FC236}">
-                <a16:creationId xmlns:a16="http://schemas.microsoft.com/office/drawing/2014/main" id="{86A493F9-CF2B-48B3-BC25-2F0FF515DC47}"/>
-              </a:ext>
-            </a:extLst>
-          </p:cNvPr>
-          <p:cNvSpPr>
-            <a:spLocks noGrp="1"/>
-          </p:cNvSpPr>
-          <p:nvPr>
-            <p:ph type="title"/>
-          </p:nvPr>
-        </p:nvSpPr>
-        <p:spPr/>
-        <p:txBody>
-          <a:bodyPr/>
-          <a:lstStyle/>
-          <a:p>
-            <a:r>
-              <a:rPr lang="en-US" dirty="0"/>
-              <a:t>Current Progress</a:t>
-            </a:r>
-          </a:p>
-        </p:txBody>
-      </p:sp>
-      <p:sp>
-        <p:nvSpPr>
-          <p:cNvPr id="4" name="Rectangle 1">
-            <a:extLst>
-              <a:ext uri="{FF2B5EF4-FFF2-40B4-BE49-F238E27FC236}">
-                <a16:creationId xmlns:a16="http://schemas.microsoft.com/office/drawing/2014/main" id="{EFE19CAC-1FD5-4663-80CD-7B10AF450E9D}"/>
-              </a:ext>
-            </a:extLst>
-          </p:cNvPr>
-          <p:cNvSpPr>
-            <a:spLocks noGrp="1" noChangeArrowheads="1"/>
-          </p:cNvSpPr>
-          <p:nvPr>
-            <p:ph idx="1"/>
-          </p:nvPr>
-        </p:nvSpPr>
-        <p:spPr bwMode="auto">
-          <a:xfrm>
-            <a:off x="1069848" y="2765756"/>
-            <a:ext cx="8654100" cy="2741776"/>
-          </a:xfrm>
-          <a:prstGeom prst="rect">
-            <a:avLst/>
-          </a:prstGeom>
-          <a:noFill/>
-          <a:ln>
-            <a:noFill/>
-          </a:ln>
-          <a:effectLst/>
-          <a:extLst>
-            <a:ext uri="{909E8E84-426E-40DD-AFC4-6F175D3DCCD1}">
-              <a14:hiddenFill xmlns:a14="http://schemas.microsoft.com/office/drawing/2010/main">
-                <a:solidFill>
-                  <a:schemeClr val="accent1"/>
-                </a:solidFill>
-              </a14:hiddenFill>
-            </a:ext>
-            <a:ext uri="{91240B29-F687-4F45-9708-019B960494DF}">
-              <a14:hiddenLine xmlns:a14="http://schemas.microsoft.com/office/drawing/2010/main" w="9525">
-                <a:solidFill>
-                  <a:schemeClr val="tx1"/>
-                </a:solidFill>
-                <a:miter lim="800000"/>
-                <a:headEnd/>
-                <a:tailEnd/>
-              </a14:hiddenLine>
-            </a:ext>
-            <a:ext uri="{AF507438-7753-43E0-B8FC-AC1667EBCBE1}">
-              <a14:hiddenEffects xmlns:a14="http://schemas.microsoft.com/office/drawing/2010/main">
-                <a:effectLst>
-                  <a:outerShdw dist="35921" dir="2700000" algn="ctr" rotWithShape="0">
-                    <a:schemeClr val="bg2"/>
-                  </a:outerShdw>
-                </a:effectLst>
-              </a14:hiddenEffects>
-            </a:ext>
-          </a:extLst>
-        </p:spPr>
-        <p:txBody>
-          <a:bodyPr vert="horz" wrap="none" lIns="91440" tIns="45720" rIns="91440" bIns="45720" numCol="1" anchor="ctr" anchorCtr="0" compatLnSpc="1">
-            <a:prstTxWarp prst="textNoShape">
-              <a:avLst/>
-            </a:prstTxWarp>
-            <a:spAutoFit/>
-          </a:bodyPr>
-          <a:lstStyle/>
-          <a:p>
-            <a:pPr marL="0" marR="0" lvl="0" indent="0" algn="l" defTabSz="914400" rtl="0" eaLnBrk="0" fontAlgn="base" latinLnBrk="0" hangingPunct="0">
-              <a:lnSpc>
-                <a:spcPct val="250000"/>
-              </a:lnSpc>
-              <a:spcBef>
-                <a:spcPct val="0"/>
-              </a:spcBef>
-              <a:spcAft>
-                <a:spcPct val="0"/>
-              </a:spcAft>
-              <a:buClrTx/>
-              <a:buSzTx/>
-              <a:buFontTx/>
-              <a:buChar char="•"/>
-              <a:tabLst/>
-            </a:pPr>
-            <a:r>
-              <a:rPr kumimoji="0" lang="en-US" altLang="en-US" sz="1800" b="1" i="0" u="none" strike="noStrike" cap="none" normalizeH="0" baseline="0" dirty="0">
-                <a:ln>
-                  <a:noFill/>
-                </a:ln>
-                <a:solidFill>
-                  <a:schemeClr val="tx1"/>
-                </a:solidFill>
-                <a:effectLst/>
-                <a:latin typeface="Arial" panose="020B0604020202020204" pitchFamily="34" charset="0"/>
-              </a:rPr>
-              <a:t>Completed:</a:t>
-            </a:r>
-            <a:r>
-              <a:rPr kumimoji="0" lang="en-US" altLang="en-US" sz="1800" b="0" i="0" u="none" strike="noStrike" cap="none" normalizeH="0" baseline="0" dirty="0">
-                <a:ln>
-                  <a:noFill/>
-                </a:ln>
-                <a:solidFill>
-                  <a:schemeClr val="tx1"/>
-                </a:solidFill>
-                <a:effectLst/>
-                <a:latin typeface="Arial" panose="020B0604020202020204" pitchFamily="34" charset="0"/>
-              </a:rPr>
-              <a:t> </a:t>
-            </a:r>
-            <a:r>
-              <a:rPr kumimoji="0" lang="en-US" altLang="en-US" sz="1600" b="0" i="0" u="none" strike="noStrike" cap="none" normalizeH="0" baseline="0" dirty="0">
-                <a:ln>
-                  <a:noFill/>
-                </a:ln>
-                <a:solidFill>
-                  <a:schemeClr val="tx1"/>
-                </a:solidFill>
-                <a:effectLst/>
-                <a:latin typeface="Arial" panose="020B0604020202020204" pitchFamily="34" charset="0"/>
-              </a:rPr>
-              <a:t>Requirement </a:t>
-            </a:r>
-            <a:r>
-              <a:rPr lang="en-US" altLang="en-US" sz="1600" dirty="0">
-                <a:latin typeface="Arial" panose="020B0604020202020204" pitchFamily="34" charset="0"/>
-              </a:rPr>
-              <a:t>G</a:t>
-            </a:r>
-            <a:r>
-              <a:rPr kumimoji="0" lang="en-US" altLang="en-US" sz="1600" b="0" i="0" u="none" strike="noStrike" cap="none" normalizeH="0" baseline="0" dirty="0">
-                <a:ln>
-                  <a:noFill/>
-                </a:ln>
-                <a:solidFill>
-                  <a:schemeClr val="tx1"/>
-                </a:solidFill>
-                <a:effectLst/>
-                <a:latin typeface="Arial" panose="020B0604020202020204" pitchFamily="34" charset="0"/>
-              </a:rPr>
-              <a:t>athering, Tech </a:t>
-            </a:r>
-            <a:r>
-              <a:rPr lang="en-US" altLang="en-US" sz="1600" dirty="0">
-                <a:latin typeface="Arial" panose="020B0604020202020204" pitchFamily="34" charset="0"/>
-              </a:rPr>
-              <a:t>S</a:t>
-            </a:r>
-            <a:r>
-              <a:rPr kumimoji="0" lang="en-US" altLang="en-US" sz="1600" b="0" i="0" u="none" strike="noStrike" cap="none" normalizeH="0" baseline="0" dirty="0">
-                <a:ln>
-                  <a:noFill/>
-                </a:ln>
-                <a:solidFill>
-                  <a:schemeClr val="tx1"/>
-                </a:solidFill>
-                <a:effectLst/>
-                <a:latin typeface="Arial" panose="020B0604020202020204" pitchFamily="34" charset="0"/>
-              </a:rPr>
-              <a:t>tack </a:t>
-            </a:r>
-            <a:r>
-              <a:rPr lang="en-US" altLang="en-US" sz="1600" dirty="0">
-                <a:latin typeface="Arial" panose="020B0604020202020204" pitchFamily="34" charset="0"/>
-              </a:rPr>
-              <a:t>G</a:t>
-            </a:r>
-            <a:r>
-              <a:rPr kumimoji="0" lang="en-US" altLang="en-US" sz="1600" b="0" i="0" u="none" strike="noStrike" cap="none" normalizeH="0" baseline="0" dirty="0">
-                <a:ln>
-                  <a:noFill/>
-                </a:ln>
-                <a:solidFill>
-                  <a:schemeClr val="tx1"/>
-                </a:solidFill>
-                <a:effectLst/>
-                <a:latin typeface="Arial" panose="020B0604020202020204" pitchFamily="34" charset="0"/>
-              </a:rPr>
-              <a:t>athering, Problem Domain Identification</a:t>
-            </a:r>
-          </a:p>
-          <a:p>
-            <a:pPr marL="0" marR="0" lvl="0" indent="0" algn="l" defTabSz="914400" rtl="0" eaLnBrk="0" fontAlgn="base" latinLnBrk="0" hangingPunct="0">
-              <a:lnSpc>
-                <a:spcPct val="250000"/>
-              </a:lnSpc>
-              <a:spcBef>
-                <a:spcPct val="0"/>
-              </a:spcBef>
-              <a:spcAft>
-                <a:spcPct val="0"/>
-              </a:spcAft>
-              <a:buClrTx/>
-              <a:buSzTx/>
-              <a:buFontTx/>
-              <a:buChar char="•"/>
-              <a:tabLst/>
-            </a:pPr>
-            <a:r>
-              <a:rPr kumimoji="0" lang="en-US" altLang="en-US" sz="1800" b="1" i="0" u="none" strike="noStrike" cap="none" normalizeH="0" baseline="0" dirty="0">
-                <a:ln>
-                  <a:noFill/>
-                </a:ln>
-                <a:solidFill>
-                  <a:schemeClr val="tx1"/>
-                </a:solidFill>
-                <a:effectLst/>
-                <a:latin typeface="Arial" panose="020B0604020202020204" pitchFamily="34" charset="0"/>
-              </a:rPr>
-              <a:t>In progress:</a:t>
-            </a:r>
-            <a:r>
-              <a:rPr kumimoji="0" lang="en-US" altLang="en-US" sz="1800" b="0" i="0" u="none" strike="noStrike" cap="none" normalizeH="0" baseline="0" dirty="0">
-                <a:ln>
-                  <a:noFill/>
-                </a:ln>
-                <a:solidFill>
-                  <a:schemeClr val="tx1"/>
-                </a:solidFill>
-                <a:effectLst/>
-                <a:latin typeface="Arial" panose="020B0604020202020204" pitchFamily="34" charset="0"/>
-              </a:rPr>
-              <a:t> </a:t>
-            </a:r>
-            <a:r>
-              <a:rPr lang="en-US" altLang="en-US" sz="1600" dirty="0">
-                <a:latin typeface="Arial Unicode MS"/>
-              </a:rPr>
-              <a:t>Wireframe Drafting, Report Drafting, Database Implementation</a:t>
-            </a:r>
-          </a:p>
-          <a:p>
-            <a:pPr marL="0" marR="0" lvl="0" indent="0" algn="l" defTabSz="914400" rtl="0" eaLnBrk="0" fontAlgn="base" latinLnBrk="0" hangingPunct="0">
-              <a:lnSpc>
-                <a:spcPct val="250000"/>
-              </a:lnSpc>
-              <a:spcBef>
-                <a:spcPct val="0"/>
-              </a:spcBef>
-              <a:spcAft>
-                <a:spcPct val="0"/>
-              </a:spcAft>
-              <a:buClrTx/>
-              <a:buSzTx/>
-              <a:buFontTx/>
-              <a:buChar char="•"/>
-              <a:tabLst/>
-            </a:pPr>
-            <a:r>
-              <a:rPr kumimoji="0" lang="en-US" altLang="en-US" sz="1800" b="1" i="0" u="none" strike="noStrike" cap="none" normalizeH="0" baseline="0" dirty="0">
-                <a:ln>
-                  <a:noFill/>
-                </a:ln>
-                <a:solidFill>
-                  <a:schemeClr val="tx1"/>
-                </a:solidFill>
-                <a:effectLst/>
-                <a:latin typeface="Arial" panose="020B0604020202020204" pitchFamily="34" charset="0"/>
-              </a:rPr>
-              <a:t>Design completed:</a:t>
-            </a:r>
-            <a:r>
-              <a:rPr kumimoji="0" lang="en-US" altLang="en-US" sz="1800" b="0" i="0" u="none" strike="noStrike" cap="none" normalizeH="0" baseline="0" dirty="0">
-                <a:ln>
-                  <a:noFill/>
-                </a:ln>
-                <a:solidFill>
-                  <a:schemeClr val="tx1"/>
-                </a:solidFill>
-                <a:effectLst/>
-                <a:latin typeface="Arial" panose="020B0604020202020204" pitchFamily="34" charset="0"/>
-              </a:rPr>
-              <a:t> </a:t>
-            </a:r>
-            <a:r>
-              <a:rPr lang="en-US" altLang="en-US" sz="1600" dirty="0">
-                <a:latin typeface="Arial Unicode MS"/>
-              </a:rPr>
-              <a:t>System Architecture, ERD, Activity Diagram and Use Case Diagram</a:t>
-            </a:r>
-            <a:endParaRPr kumimoji="0" lang="en-US" altLang="en-US" sz="1600" b="0" i="0" u="none" strike="noStrike" cap="none" normalizeH="0" baseline="0" dirty="0">
-              <a:ln>
-                <a:noFill/>
-              </a:ln>
-              <a:solidFill>
-                <a:schemeClr val="tx1"/>
-              </a:solidFill>
-              <a:effectLst/>
-              <a:latin typeface="Arial" panose="020B0604020202020204" pitchFamily="34" charset="0"/>
-            </a:endParaRPr>
-          </a:p>
-          <a:p>
-            <a:pPr marL="0" marR="0" lvl="0" indent="0" algn="l" defTabSz="914400" rtl="0" eaLnBrk="0" fontAlgn="base" latinLnBrk="0" hangingPunct="0">
-              <a:lnSpc>
-                <a:spcPct val="250000"/>
-              </a:lnSpc>
-              <a:spcBef>
-                <a:spcPct val="0"/>
-              </a:spcBef>
-              <a:spcAft>
-                <a:spcPct val="0"/>
-              </a:spcAft>
-              <a:buClrTx/>
-              <a:buSzTx/>
-              <a:buFontTx/>
-              <a:buChar char="•"/>
-              <a:tabLst/>
-            </a:pPr>
-            <a:r>
-              <a:rPr kumimoji="0" lang="en-US" altLang="en-US" sz="1800" b="1" i="0" u="none" strike="noStrike" cap="none" normalizeH="0" baseline="0" dirty="0">
-                <a:ln>
-                  <a:noFill/>
-                </a:ln>
-                <a:solidFill>
-                  <a:schemeClr val="tx1"/>
-                </a:solidFill>
-                <a:effectLst/>
-                <a:latin typeface="Arial" panose="020B0604020202020204" pitchFamily="34" charset="0"/>
-              </a:rPr>
-              <a:t>Remaining: </a:t>
-            </a:r>
-            <a:r>
-              <a:rPr kumimoji="0" lang="en-US" altLang="en-US" sz="1600" i="0" u="none" strike="noStrike" cap="none" normalizeH="0" baseline="0" dirty="0">
-                <a:ln>
-                  <a:noFill/>
-                </a:ln>
-                <a:solidFill>
-                  <a:schemeClr val="tx1"/>
-                </a:solidFill>
-                <a:effectLst/>
-                <a:latin typeface="Arial" panose="020B0604020202020204" pitchFamily="34" charset="0"/>
-              </a:rPr>
-              <a:t>Backend</a:t>
-            </a:r>
-            <a:r>
-              <a:rPr kumimoji="0" lang="en-US" altLang="en-US" sz="1600" b="1" i="0" u="none" strike="noStrike" cap="none" normalizeH="0" baseline="0" dirty="0">
-                <a:ln>
-                  <a:noFill/>
-                </a:ln>
-                <a:solidFill>
-                  <a:schemeClr val="tx1"/>
-                </a:solidFill>
-                <a:effectLst/>
-                <a:latin typeface="Arial" panose="020B0604020202020204" pitchFamily="34" charset="0"/>
-              </a:rPr>
-              <a:t> </a:t>
-            </a:r>
-            <a:r>
-              <a:rPr kumimoji="0" lang="en-US" altLang="en-US" sz="1600" i="0" u="none" strike="noStrike" cap="none" normalizeH="0" baseline="0" dirty="0">
-                <a:ln>
-                  <a:noFill/>
-                </a:ln>
-                <a:solidFill>
-                  <a:schemeClr val="tx1"/>
-                </a:solidFill>
-                <a:effectLst/>
-                <a:latin typeface="Arial" panose="020B0604020202020204" pitchFamily="34" charset="0"/>
-              </a:rPr>
-              <a:t>Implementation, Frontend Implementation, Testing, </a:t>
-            </a:r>
-            <a:endParaRPr kumimoji="0" lang="en-US" altLang="en-US" sz="1800" i="0" u="none" strike="noStrike" cap="none" normalizeH="0" baseline="0" dirty="0">
-              <a:ln>
-                <a:noFill/>
-              </a:ln>
-              <a:solidFill>
-                <a:schemeClr val="tx1"/>
-              </a:solidFill>
-              <a:effectLst/>
-              <a:latin typeface="Arial" panose="020B0604020202020204" pitchFamily="34" charset="0"/>
-            </a:endParaRPr>
-          </a:p>
-        </p:txBody>
-      </p:sp>
-    </p:spTree>
-    <p:extLst>
-      <p:ext uri="{BB962C8B-B14F-4D97-AF65-F5344CB8AC3E}">
-        <p14:creationId xmlns:p14="http://schemas.microsoft.com/office/powerpoint/2010/main" val="1192335521"/>
-      </p:ext>
-    </p:extLst>
-  </p:cSld>
-  <p:clrMapOvr>
-    <a:masterClrMapping/>
-  </p:clrMapOvr>
-</p:sld>
-</file>
-
 <file path=ppt/slides/slide23.xml><?xml version="1.0" encoding="utf-8"?>
 <p:sld xmlns:a="http://schemas.openxmlformats.org/drawingml/2006/main" xmlns:r="http://schemas.openxmlformats.org/officeDocument/2006/relationships" xmlns:p="http://schemas.openxmlformats.org/presentationml/2006/main">
   <p:cSld>
@@ -7364,7 +6958,7 @@
           <p:cNvPr id="2" name="Title 1">
             <a:extLst>
               <a:ext uri="{FF2B5EF4-FFF2-40B4-BE49-F238E27FC236}">
-                <a16:creationId xmlns:a16="http://schemas.microsoft.com/office/drawing/2014/main" id="{6A7F67C3-6D6E-4475-8EBF-49268E399D15}"/>
+                <a16:creationId xmlns:a16="http://schemas.microsoft.com/office/drawing/2014/main" id="{86A493F9-CF2B-48B3-BC25-2F0FF515DC47}"/>
               </a:ext>
             </a:extLst>
           </p:cNvPr>
@@ -7382,195 +6976,360 @@
           <a:p>
             <a:r>
               <a:rPr lang="en-US" dirty="0"/>
-              <a:t>Next Steps</a:t>
-            </a:r>
-          </a:p>
-        </p:txBody>
-      </p:sp>
-      <p:sp>
-        <p:nvSpPr>
-          <p:cNvPr id="4" name="Rectangle 1">
+              <a:t>Implementation: Tech Stack</a:t>
+            </a:r>
+          </a:p>
+        </p:txBody>
+      </p:sp>
+      <p:graphicFrame>
+        <p:nvGraphicFramePr>
+          <p:cNvPr id="3" name="Table 2">
             <a:extLst>
               <a:ext uri="{FF2B5EF4-FFF2-40B4-BE49-F238E27FC236}">
-                <a16:creationId xmlns:a16="http://schemas.microsoft.com/office/drawing/2014/main" id="{39E5A8E0-18F3-4B36-A52F-06D4259CF4F3}"/>
+                <a16:creationId xmlns:a16="http://schemas.microsoft.com/office/drawing/2014/main" id="{4E62EE6C-B119-4116-8BEB-B404F868505D}"/>
               </a:ext>
             </a:extLst>
           </p:cNvPr>
-          <p:cNvSpPr>
-            <a:spLocks noGrp="1" noChangeArrowheads="1"/>
-          </p:cNvSpPr>
-          <p:nvPr>
-            <p:ph idx="1"/>
-          </p:nvPr>
-        </p:nvSpPr>
-        <p:spPr bwMode="auto">
-          <a:xfrm>
-            <a:off x="1069848" y="2775916"/>
-            <a:ext cx="10058400" cy="2741776"/>
-          </a:xfrm>
-          <a:prstGeom prst="rect">
-            <a:avLst/>
-          </a:prstGeom>
-          <a:noFill/>
-          <a:ln>
-            <a:noFill/>
-          </a:ln>
-          <a:effectLst/>
-          <a:extLst>
-            <a:ext uri="{909E8E84-426E-40DD-AFC4-6F175D3DCCD1}">
-              <a14:hiddenFill xmlns:a14="http://schemas.microsoft.com/office/drawing/2010/main">
-                <a:solidFill>
-                  <a:schemeClr val="accent1"/>
-                </a:solidFill>
-              </a14:hiddenFill>
-            </a:ext>
-            <a:ext uri="{91240B29-F687-4F45-9708-019B960494DF}">
-              <a14:hiddenLine xmlns:a14="http://schemas.microsoft.com/office/drawing/2010/main" w="9525">
-                <a:solidFill>
-                  <a:schemeClr val="tx1"/>
-                </a:solidFill>
-                <a:miter lim="800000"/>
-                <a:headEnd/>
-                <a:tailEnd/>
-              </a14:hiddenLine>
-            </a:ext>
-            <a:ext uri="{AF507438-7753-43E0-B8FC-AC1667EBCBE1}">
-              <a14:hiddenEffects xmlns:a14="http://schemas.microsoft.com/office/drawing/2010/main">
-                <a:effectLst>
-                  <a:outerShdw dist="35921" dir="2700000" algn="ctr" rotWithShape="0">
-                    <a:schemeClr val="bg2"/>
-                  </a:outerShdw>
-                </a:effectLst>
-              </a14:hiddenEffects>
-            </a:ext>
-          </a:extLst>
-        </p:spPr>
-        <p:txBody>
-          <a:bodyPr vert="horz" wrap="square" lIns="91440" tIns="45720" rIns="91440" bIns="45720" numCol="1" anchor="ctr" anchorCtr="0" compatLnSpc="1">
-            <a:prstTxWarp prst="textNoShape">
-              <a:avLst/>
-            </a:prstTxWarp>
-            <a:spAutoFit/>
-          </a:bodyPr>
-          <a:lstStyle/>
-          <a:p>
-            <a:pPr eaLnBrk="0" fontAlgn="base" hangingPunct="0">
-              <a:lnSpc>
-                <a:spcPct val="250000"/>
-              </a:lnSpc>
-              <a:spcBef>
-                <a:spcPct val="0"/>
-              </a:spcBef>
-              <a:spcAft>
-                <a:spcPct val="0"/>
-              </a:spcAft>
-              <a:buClrTx/>
-              <a:buSzTx/>
-            </a:pPr>
-            <a:r>
-              <a:rPr kumimoji="0" lang="en-US" altLang="en-US" sz="1800" b="0" i="0" u="none" strike="noStrike" cap="none" normalizeH="0" baseline="0" dirty="0">
-                <a:ln>
-                  <a:noFill/>
-                </a:ln>
-                <a:solidFill>
-                  <a:schemeClr val="tx1"/>
-                </a:solidFill>
-                <a:effectLst/>
-                <a:latin typeface="Arial" panose="020B0604020202020204" pitchFamily="34" charset="0"/>
-              </a:rPr>
-              <a:t>Complete core database and backend implementation </a:t>
-            </a:r>
-          </a:p>
-          <a:p>
-            <a:pPr eaLnBrk="0" fontAlgn="base" hangingPunct="0">
-              <a:lnSpc>
-                <a:spcPct val="250000"/>
-              </a:lnSpc>
-              <a:spcBef>
-                <a:spcPct val="0"/>
-              </a:spcBef>
-              <a:spcAft>
-                <a:spcPct val="0"/>
-              </a:spcAft>
-              <a:buClrTx/>
-              <a:buSzTx/>
-            </a:pPr>
-            <a:r>
-              <a:rPr kumimoji="0" lang="en-US" altLang="en-US" sz="1800" b="0" i="0" u="none" strike="noStrike" cap="none" normalizeH="0" baseline="0" dirty="0">
-                <a:ln>
-                  <a:noFill/>
-                </a:ln>
-                <a:solidFill>
-                  <a:schemeClr val="tx1"/>
-                </a:solidFill>
-                <a:effectLst/>
-                <a:latin typeface="Arial" panose="020B0604020202020204" pitchFamily="34" charset="0"/>
-              </a:rPr>
-              <a:t>Implement task, project and collaboration workflows </a:t>
-            </a:r>
-          </a:p>
-          <a:p>
-            <a:pPr eaLnBrk="0" fontAlgn="base" hangingPunct="0">
-              <a:lnSpc>
-                <a:spcPct val="250000"/>
-              </a:lnSpc>
-              <a:spcBef>
-                <a:spcPct val="0"/>
-              </a:spcBef>
-              <a:spcAft>
-                <a:spcPct val="0"/>
-              </a:spcAft>
-              <a:buClrTx/>
-              <a:buSzTx/>
-            </a:pPr>
-            <a:r>
-              <a:rPr kumimoji="0" lang="en-US" altLang="en-US" sz="1800" b="0" i="0" u="none" strike="noStrike" cap="none" normalizeH="0" baseline="0" dirty="0">
-                <a:ln>
-                  <a:noFill/>
-                </a:ln>
-                <a:solidFill>
-                  <a:schemeClr val="tx1"/>
-                </a:solidFill>
-                <a:effectLst/>
-                <a:latin typeface="Arial" panose="020B0604020202020204" pitchFamily="34" charset="0"/>
-              </a:rPr>
-              <a:t>Integrate progress, work-hour and dependency functionality </a:t>
-            </a:r>
-          </a:p>
-          <a:p>
-            <a:pPr eaLnBrk="0" fontAlgn="base" hangingPunct="0">
-              <a:lnSpc>
-                <a:spcPct val="250000"/>
-              </a:lnSpc>
-              <a:spcBef>
-                <a:spcPct val="0"/>
-              </a:spcBef>
-              <a:spcAft>
-                <a:spcPct val="0"/>
-              </a:spcAft>
-              <a:buClrTx/>
-              <a:buSzTx/>
-            </a:pPr>
-            <a:r>
-              <a:rPr kumimoji="0" lang="en-US" altLang="en-US" sz="1800" b="0" i="0" u="none" strike="noStrike" cap="none" normalizeH="0" baseline="0" dirty="0">
-                <a:ln>
-                  <a:noFill/>
-                </a:ln>
-                <a:solidFill>
-                  <a:schemeClr val="tx1"/>
-                </a:solidFill>
-                <a:effectLst/>
-                <a:latin typeface="Arial" panose="020B0604020202020204" pitchFamily="34" charset="0"/>
-              </a:rPr>
-              <a:t>Test system behavior and refine the MVP </a:t>
-            </a:r>
-          </a:p>
-        </p:txBody>
-      </p:sp>
+          <p:cNvGraphicFramePr>
+            <a:graphicFrameLocks noGrp="1"/>
+          </p:cNvGraphicFramePr>
+          <p:nvPr>
+            <p:extLst>
+              <p:ext uri="{D42A27DB-BD31-4B8C-83A1-F6EECF244321}">
+                <p14:modId xmlns:p14="http://schemas.microsoft.com/office/powerpoint/2010/main" val="1610247035"/>
+              </p:ext>
+            </p:extLst>
+          </p:nvPr>
+        </p:nvGraphicFramePr>
+        <p:xfrm>
+          <a:off x="1063752" y="2093976"/>
+          <a:ext cx="9196354" cy="4051787"/>
+        </p:xfrm>
+        <a:graphic>
+          <a:graphicData uri="http://schemas.openxmlformats.org/drawingml/2006/table">
+            <a:tbl>
+              <a:tblPr/>
+              <a:tblGrid>
+                <a:gridCol w="4598177">
+                  <a:extLst>
+                    <a:ext uri="{9D8B030D-6E8A-4147-A177-3AD203B41FA5}">
+                      <a16:colId xmlns:a16="http://schemas.microsoft.com/office/drawing/2014/main" val="3559121290"/>
+                    </a:ext>
+                  </a:extLst>
+                </a:gridCol>
+                <a:gridCol w="4598177">
+                  <a:extLst>
+                    <a:ext uri="{9D8B030D-6E8A-4147-A177-3AD203B41FA5}">
+                      <a16:colId xmlns:a16="http://schemas.microsoft.com/office/drawing/2014/main" val="183285802"/>
+                    </a:ext>
+                  </a:extLst>
+                </a:gridCol>
+              </a:tblGrid>
+              <a:tr h="344791">
+                <a:tc>
+                  <a:txBody>
+                    <a:bodyPr/>
+                    <a:lstStyle/>
+                    <a:p>
+                      <a:r>
+                        <a:rPr lang="en-US" sz="1700"/>
+                        <a:t>Layer</a:t>
+                      </a:r>
+                    </a:p>
+                  </a:txBody>
+                  <a:tcPr marL="86198" marR="86198" marT="43099" marB="43099" anchor="ctr">
+                    <a:lnL>
+                      <a:noFill/>
+                    </a:lnL>
+                    <a:lnR>
+                      <a:noFill/>
+                    </a:lnR>
+                    <a:lnT>
+                      <a:noFill/>
+                    </a:lnT>
+                    <a:lnB>
+                      <a:noFill/>
+                    </a:lnB>
+                  </a:tcPr>
+                </a:tc>
+                <a:tc>
+                  <a:txBody>
+                    <a:bodyPr/>
+                    <a:lstStyle/>
+                    <a:p>
+                      <a:r>
+                        <a:rPr lang="en-US" sz="1700" dirty="0"/>
+                        <a:t>Technology</a:t>
+                      </a:r>
+                    </a:p>
+                  </a:txBody>
+                  <a:tcPr marL="86198" marR="86198" marT="43099" marB="43099" anchor="ctr">
+                    <a:lnL>
+                      <a:noFill/>
+                    </a:lnL>
+                    <a:lnR>
+                      <a:noFill/>
+                    </a:lnR>
+                    <a:lnT>
+                      <a:noFill/>
+                    </a:lnT>
+                    <a:lnB>
+                      <a:noFill/>
+                    </a:lnB>
+                  </a:tcPr>
+                </a:tc>
+                <a:extLst>
+                  <a:ext uri="{0D108BD9-81ED-4DB2-BD59-A6C34878D82A}">
+                    <a16:rowId xmlns:a16="http://schemas.microsoft.com/office/drawing/2014/main" val="3925711979"/>
+                  </a:ext>
+                </a:extLst>
+              </a:tr>
+              <a:tr h="861979">
+                <a:tc>
+                  <a:txBody>
+                    <a:bodyPr/>
+                    <a:lstStyle/>
+                    <a:p>
+                      <a:r>
+                        <a:rPr lang="en-US" sz="1700" b="1" dirty="0"/>
+                        <a:t>Frontend</a:t>
+                      </a:r>
+                      <a:endParaRPr lang="en-US" sz="1700" dirty="0"/>
+                    </a:p>
+                  </a:txBody>
+                  <a:tcPr marL="86198" marR="86198" marT="43099" marB="43099" anchor="ctr">
+                    <a:lnL>
+                      <a:noFill/>
+                    </a:lnL>
+                    <a:lnR>
+                      <a:noFill/>
+                    </a:lnR>
+                    <a:lnT>
+                      <a:noFill/>
+                    </a:lnT>
+                    <a:lnB>
+                      <a:noFill/>
+                    </a:lnB>
+                  </a:tcPr>
+                </a:tc>
+                <a:tc>
+                  <a:txBody>
+                    <a:bodyPr/>
+                    <a:lstStyle/>
+                    <a:p>
+                      <a:r>
+                        <a:rPr lang="fr-FR" sz="1700" b="1" dirty="0"/>
+                        <a:t>HTML5 + CSS3 + JavaScript (ES Modules)</a:t>
+                      </a:r>
+                      <a:endParaRPr lang="fr-FR" sz="1700" dirty="0"/>
+                    </a:p>
+                  </a:txBody>
+                  <a:tcPr marL="86198" marR="86198" marT="43099" marB="43099" anchor="ctr">
+                    <a:lnL>
+                      <a:noFill/>
+                    </a:lnL>
+                    <a:lnR>
+                      <a:noFill/>
+                    </a:lnR>
+                    <a:lnT>
+                      <a:noFill/>
+                    </a:lnT>
+                    <a:lnB>
+                      <a:noFill/>
+                    </a:lnB>
+                  </a:tcPr>
+                </a:tc>
+                <a:extLst>
+                  <a:ext uri="{0D108BD9-81ED-4DB2-BD59-A6C34878D82A}">
+                    <a16:rowId xmlns:a16="http://schemas.microsoft.com/office/drawing/2014/main" val="3050604399"/>
+                  </a:ext>
+                </a:extLst>
+              </a:tr>
+              <a:tr h="861979">
+                <a:tc>
+                  <a:txBody>
+                    <a:bodyPr/>
+                    <a:lstStyle/>
+                    <a:p>
+                      <a:r>
+                        <a:rPr lang="en-US" sz="1700" b="1"/>
+                        <a:t>Backend</a:t>
+                      </a:r>
+                      <a:endParaRPr lang="en-US" sz="1700"/>
+                    </a:p>
+                  </a:txBody>
+                  <a:tcPr marL="86198" marR="86198" marT="43099" marB="43099" anchor="ctr">
+                    <a:lnL>
+                      <a:noFill/>
+                    </a:lnL>
+                    <a:lnR>
+                      <a:noFill/>
+                    </a:lnR>
+                    <a:lnT>
+                      <a:noFill/>
+                    </a:lnT>
+                    <a:lnB>
+                      <a:noFill/>
+                    </a:lnB>
+                  </a:tcPr>
+                </a:tc>
+                <a:tc>
+                  <a:txBody>
+                    <a:bodyPr/>
+                    <a:lstStyle/>
+                    <a:p>
+                      <a:r>
+                        <a:rPr lang="en-US" sz="1700" b="1" dirty="0"/>
+                        <a:t>Node.js + Express-style HTTP routing</a:t>
+                      </a:r>
+                      <a:endParaRPr lang="en-US" sz="1700" dirty="0"/>
+                    </a:p>
+                  </a:txBody>
+                  <a:tcPr marL="86198" marR="86198" marT="43099" marB="43099" anchor="ctr">
+                    <a:lnL>
+                      <a:noFill/>
+                    </a:lnL>
+                    <a:lnR>
+                      <a:noFill/>
+                    </a:lnR>
+                    <a:lnT>
+                      <a:noFill/>
+                    </a:lnT>
+                    <a:lnB>
+                      <a:noFill/>
+                    </a:lnB>
+                  </a:tcPr>
+                </a:tc>
+                <a:extLst>
+                  <a:ext uri="{0D108BD9-81ED-4DB2-BD59-A6C34878D82A}">
+                    <a16:rowId xmlns:a16="http://schemas.microsoft.com/office/drawing/2014/main" val="3245577118"/>
+                  </a:ext>
+                </a:extLst>
+              </a:tr>
+              <a:tr h="1379166">
+                <a:tc>
+                  <a:txBody>
+                    <a:bodyPr/>
+                    <a:lstStyle/>
+                    <a:p>
+                      <a:r>
+                        <a:rPr lang="en-US" sz="1700" b="1"/>
+                        <a:t>Database</a:t>
+                      </a:r>
+                      <a:endParaRPr lang="en-US" sz="1700"/>
+                    </a:p>
+                  </a:txBody>
+                  <a:tcPr marL="86198" marR="86198" marT="43099" marB="43099" anchor="ctr">
+                    <a:lnL>
+                      <a:noFill/>
+                    </a:lnL>
+                    <a:lnR>
+                      <a:noFill/>
+                    </a:lnR>
+                    <a:lnT>
+                      <a:noFill/>
+                    </a:lnT>
+                    <a:lnB>
+                      <a:noFill/>
+                    </a:lnB>
+                  </a:tcPr>
+                </a:tc>
+                <a:tc>
+                  <a:txBody>
+                    <a:bodyPr/>
+                    <a:lstStyle/>
+                    <a:p>
+                      <a:r>
+                        <a:rPr lang="en-US" sz="1700" b="1" dirty="0"/>
+                        <a:t>MySQL 8.x</a:t>
+                      </a:r>
+                      <a:endParaRPr lang="en-US" sz="1700" dirty="0"/>
+                    </a:p>
+                  </a:txBody>
+                  <a:tcPr marL="86198" marR="86198" marT="43099" marB="43099" anchor="ctr">
+                    <a:lnL>
+                      <a:noFill/>
+                    </a:lnL>
+                    <a:lnR>
+                      <a:noFill/>
+                    </a:lnR>
+                    <a:lnT>
+                      <a:noFill/>
+                    </a:lnT>
+                    <a:lnB>
+                      <a:noFill/>
+                    </a:lnB>
+                  </a:tcPr>
+                </a:tc>
+                <a:extLst>
+                  <a:ext uri="{0D108BD9-81ED-4DB2-BD59-A6C34878D82A}">
+                    <a16:rowId xmlns:a16="http://schemas.microsoft.com/office/drawing/2014/main" val="4024261398"/>
+                  </a:ext>
+                </a:extLst>
+              </a:tr>
+              <a:tr h="603385">
+                <a:tc>
+                  <a:txBody>
+                    <a:bodyPr/>
+                    <a:lstStyle/>
+                    <a:p>
+                      <a:r>
+                        <a:rPr lang="en-US" sz="1700" b="1"/>
+                        <a:t>Communication / Networking</a:t>
+                      </a:r>
+                      <a:endParaRPr lang="en-US" sz="1700"/>
+                    </a:p>
+                  </a:txBody>
+                  <a:tcPr marL="86198" marR="86198" marT="43099" marB="43099" anchor="ctr">
+                    <a:lnL>
+                      <a:noFill/>
+                    </a:lnL>
+                    <a:lnR>
+                      <a:noFill/>
+                    </a:lnR>
+                    <a:lnT>
+                      <a:noFill/>
+                    </a:lnT>
+                    <a:lnB>
+                      <a:noFill/>
+                    </a:lnB>
+                  </a:tcPr>
+                </a:tc>
+                <a:tc>
+                  <a:txBody>
+                    <a:bodyPr/>
+                    <a:lstStyle/>
+                    <a:p>
+                      <a:r>
+                        <a:rPr lang="en-US" sz="1700" b="1" dirty="0"/>
+                        <a:t>HTTP/REST API + JSON + session cookies</a:t>
+                      </a:r>
+                      <a:endParaRPr lang="en-US" sz="1700" dirty="0"/>
+                    </a:p>
+                  </a:txBody>
+                  <a:tcPr marL="86198" marR="86198" marT="43099" marB="43099" anchor="ctr">
+                    <a:lnL>
+                      <a:noFill/>
+                    </a:lnL>
+                    <a:lnT>
+                      <a:noFill/>
+                    </a:lnT>
+                  </a:tcPr>
+                </a:tc>
+                <a:extLst>
+                  <a:ext uri="{0D108BD9-81ED-4DB2-BD59-A6C34878D82A}">
+                    <a16:rowId xmlns:a16="http://schemas.microsoft.com/office/drawing/2014/main" val="3781700582"/>
+                  </a:ext>
+                </a:extLst>
+              </a:tr>
+            </a:tbl>
+          </a:graphicData>
+        </a:graphic>
+      </p:graphicFrame>
     </p:spTree>
     <p:extLst>
       <p:ext uri="{BB962C8B-B14F-4D97-AF65-F5344CB8AC3E}">
-        <p14:creationId xmlns:p14="http://schemas.microsoft.com/office/powerpoint/2010/main" val="235985688"/>
+        <p14:creationId xmlns:p14="http://schemas.microsoft.com/office/powerpoint/2010/main" val="1192335521"/>
       </p:ext>
     </p:extLst>
   </p:cSld>
@@ -7602,7 +7361,7 @@
           <p:cNvPr id="2" name="Title 1">
             <a:extLst>
               <a:ext uri="{FF2B5EF4-FFF2-40B4-BE49-F238E27FC236}">
-                <a16:creationId xmlns:a16="http://schemas.microsoft.com/office/drawing/2014/main" id="{D0325DC4-1DFD-4FC6-A884-9A5E62D118CF}"/>
+                <a16:creationId xmlns:a16="http://schemas.microsoft.com/office/drawing/2014/main" id="{6A7F67C3-6D6E-4475-8EBF-49268E399D15}"/>
               </a:ext>
             </a:extLst>
           </p:cNvPr>
@@ -7620,7 +7379,7 @@
           <a:p>
             <a:r>
               <a:rPr lang="en-US" dirty="0"/>
-              <a:t>Summary</a:t>
+              <a:t>Implementation: Mock Ups</a:t>
             </a:r>
           </a:p>
         </p:txBody>
@@ -7630,7 +7389,7 @@
           <p:cNvPr id="4" name="Rectangle 1">
             <a:extLst>
               <a:ext uri="{FF2B5EF4-FFF2-40B4-BE49-F238E27FC236}">
-                <a16:creationId xmlns:a16="http://schemas.microsoft.com/office/drawing/2014/main" id="{08130F10-A9D9-48A0-B66B-AABF0F591093}"/>
+                <a16:creationId xmlns:a16="http://schemas.microsoft.com/office/drawing/2014/main" id="{39E5A8E0-18F3-4B36-A52F-06D4259CF4F3}"/>
               </a:ext>
             </a:extLst>
           </p:cNvPr>
@@ -7643,8 +7402,8 @@
         </p:nvSpPr>
         <p:spPr bwMode="auto">
           <a:xfrm>
-            <a:off x="1069848" y="2760151"/>
-            <a:ext cx="3780522" cy="2741776"/>
+            <a:off x="1069848" y="2219846"/>
+            <a:ext cx="10058400" cy="3884397"/>
           </a:xfrm>
           <a:prstGeom prst="rect">
             <a:avLst/>
@@ -7684,7 +7443,7 @@
           </a:extLst>
         </p:spPr>
         <p:txBody>
-          <a:bodyPr vert="horz" wrap="none" lIns="91440" tIns="45720" rIns="91440" bIns="45720" numCol="1" anchor="ctr" anchorCtr="0" compatLnSpc="1">
+          <a:bodyPr vert="horz" wrap="square" lIns="91440" tIns="45720" rIns="91440" bIns="45720" numCol="1" anchor="ctr" anchorCtr="0" compatLnSpc="1">
             <a:prstTxWarp prst="textNoShape">
               <a:avLst/>
             </a:prstTxWarp>
@@ -7694,7 +7453,7 @@
           <a:p>
             <a:pPr eaLnBrk="0" fontAlgn="base" hangingPunct="0">
               <a:lnSpc>
-                <a:spcPct val="250000"/>
+                <a:spcPct val="200000"/>
               </a:lnSpc>
               <a:spcBef>
                 <a:spcPct val="0"/>
@@ -7706,7 +7465,7 @@
               <a:buSzTx/>
             </a:pPr>
             <a:r>
-              <a:rPr kumimoji="0" lang="en-US" altLang="en-US" sz="1800" i="0" u="none" strike="noStrike" cap="none" normalizeH="0" baseline="0" dirty="0">
+              <a:rPr kumimoji="0" lang="en-US" altLang="en-US" sz="1800" b="0" i="0" u="none" strike="noStrike" cap="none" normalizeH="0" baseline="0" dirty="0">
                 <a:ln>
                   <a:noFill/>
                 </a:ln>
@@ -7716,13 +7475,13 @@
                 <a:effectLst/>
                 <a:latin typeface="Arial" panose="020B0604020202020204" pitchFamily="34" charset="0"/>
               </a:rPr>
-              <a:t>Problem Identified </a:t>
+              <a:t>Login Page</a:t>
             </a:r>
           </a:p>
           <a:p>
             <a:pPr eaLnBrk="0" fontAlgn="base" hangingPunct="0">
               <a:lnSpc>
-                <a:spcPct val="250000"/>
+                <a:spcPct val="200000"/>
               </a:lnSpc>
               <a:spcBef>
                 <a:spcPct val="0"/>
@@ -7734,23 +7493,16 @@
               <a:buSzTx/>
             </a:pPr>
             <a:r>
-              <a:rPr kumimoji="0" lang="en-US" altLang="en-US" sz="1800" i="0" u="none" strike="noStrike" cap="none" normalizeH="0" baseline="0" dirty="0">
-                <a:ln>
-                  <a:noFill/>
-                </a:ln>
-                <a:solidFill>
-                  <a:schemeClr val="tx1"/>
-                </a:solidFill>
-                <a:effectLst/>
+              <a:rPr lang="en-US" altLang="en-US" sz="1800" dirty="0">
                 <a:latin typeface="Arial" panose="020B0604020202020204" pitchFamily="34" charset="0"/>
               </a:rPr>
-              <a:t>Research &amp; Elicitation </a:t>
+              <a:t>Home Page</a:t>
             </a:r>
           </a:p>
           <a:p>
             <a:pPr eaLnBrk="0" fontAlgn="base" hangingPunct="0">
               <a:lnSpc>
-                <a:spcPct val="250000"/>
+                <a:spcPct val="200000"/>
               </a:lnSpc>
               <a:spcBef>
                 <a:spcPct val="0"/>
@@ -7762,7 +7514,7 @@
               <a:buSzTx/>
             </a:pPr>
             <a:r>
-              <a:rPr kumimoji="0" lang="en-US" altLang="en-US" sz="1800" i="0" u="none" strike="noStrike" cap="none" normalizeH="0" baseline="0" dirty="0">
+              <a:rPr kumimoji="0" lang="en-US" altLang="en-US" sz="1800" b="0" i="0" u="none" strike="noStrike" cap="none" normalizeH="0" baseline="0" dirty="0">
                 <a:ln>
                   <a:noFill/>
                 </a:ln>
@@ -7772,13 +7524,13 @@
                 <a:effectLst/>
                 <a:latin typeface="Arial" panose="020B0604020202020204" pitchFamily="34" charset="0"/>
               </a:rPr>
-              <a:t>Requirements &amp; Domains </a:t>
+              <a:t>Task Page</a:t>
             </a:r>
           </a:p>
           <a:p>
             <a:pPr eaLnBrk="0" fontAlgn="base" hangingPunct="0">
               <a:lnSpc>
-                <a:spcPct val="250000"/>
+                <a:spcPct val="200000"/>
               </a:lnSpc>
               <a:spcBef>
                 <a:spcPct val="0"/>
@@ -7790,7 +7542,7 @@
               <a:buSzTx/>
             </a:pPr>
             <a:r>
-              <a:rPr kumimoji="0" lang="en-US" altLang="en-US" sz="1800" i="0" u="none" strike="noStrike" cap="none" normalizeH="0" baseline="0" dirty="0">
+              <a:rPr kumimoji="0" lang="en-US" altLang="en-US" sz="1800" b="0" i="0" u="none" strike="noStrike" cap="none" normalizeH="0" baseline="0" dirty="0">
                 <a:ln>
                   <a:noFill/>
                 </a:ln>
@@ -7800,15 +7552,96 @@
                 <a:effectLst/>
                 <a:latin typeface="Arial" panose="020B0604020202020204" pitchFamily="34" charset="0"/>
               </a:rPr>
-              <a:t>System Design &amp; Implementation</a:t>
-            </a:r>
+              <a:t>Analytics Page</a:t>
+            </a:r>
+          </a:p>
+          <a:p>
+            <a:pPr eaLnBrk="0" fontAlgn="base" hangingPunct="0">
+              <a:lnSpc>
+                <a:spcPct val="200000"/>
+              </a:lnSpc>
+              <a:spcBef>
+                <a:spcPct val="0"/>
+              </a:spcBef>
+              <a:spcAft>
+                <a:spcPct val="0"/>
+              </a:spcAft>
+              <a:buClrTx/>
+              <a:buSzTx/>
+            </a:pPr>
+            <a:r>
+              <a:rPr lang="en-US" altLang="en-US" sz="1800" dirty="0">
+                <a:latin typeface="Arial" panose="020B0604020202020204" pitchFamily="34" charset="0"/>
+              </a:rPr>
+              <a:t>Project Contributor Page</a:t>
+            </a:r>
+            <a:endParaRPr kumimoji="0" lang="en-US" altLang="en-US" sz="1800" b="0" i="0" u="none" strike="noStrike" cap="none" normalizeH="0" baseline="0" dirty="0">
+              <a:ln>
+                <a:noFill/>
+              </a:ln>
+              <a:solidFill>
+                <a:schemeClr val="tx1"/>
+              </a:solidFill>
+              <a:effectLst/>
+              <a:latin typeface="Arial" panose="020B0604020202020204" pitchFamily="34" charset="0"/>
+            </a:endParaRPr>
+          </a:p>
+          <a:p>
+            <a:pPr eaLnBrk="0" fontAlgn="base" hangingPunct="0">
+              <a:lnSpc>
+                <a:spcPct val="200000"/>
+              </a:lnSpc>
+              <a:spcBef>
+                <a:spcPct val="0"/>
+              </a:spcBef>
+              <a:spcAft>
+                <a:spcPct val="0"/>
+              </a:spcAft>
+              <a:buClrTx/>
+              <a:buSzTx/>
+            </a:pPr>
+            <a:endParaRPr kumimoji="0" lang="en-US" altLang="en-US" sz="1800" b="0" i="0" u="none" strike="noStrike" cap="none" normalizeH="0" baseline="0" dirty="0">
+              <a:ln>
+                <a:noFill/>
+              </a:ln>
+              <a:solidFill>
+                <a:schemeClr val="tx1"/>
+              </a:solidFill>
+              <a:effectLst/>
+              <a:latin typeface="Arial" panose="020B0604020202020204" pitchFamily="34" charset="0"/>
+            </a:endParaRPr>
+          </a:p>
+          <a:p>
+            <a:pPr eaLnBrk="0" fontAlgn="base" hangingPunct="0">
+              <a:lnSpc>
+                <a:spcPct val="200000"/>
+              </a:lnSpc>
+              <a:spcBef>
+                <a:spcPct val="0"/>
+              </a:spcBef>
+              <a:spcAft>
+                <a:spcPct val="0"/>
+              </a:spcAft>
+              <a:buClrTx/>
+              <a:buSzTx/>
+            </a:pPr>
+            <a:endParaRPr kumimoji="0" lang="en-US" altLang="en-US" sz="1800" b="0" i="0" u="none" strike="noStrike" cap="none" normalizeH="0" baseline="0" dirty="0">
+              <a:ln>
+                <a:noFill/>
+              </a:ln>
+              <a:solidFill>
+                <a:schemeClr val="tx1"/>
+              </a:solidFill>
+              <a:effectLst/>
+              <a:latin typeface="Arial" panose="020B0604020202020204" pitchFamily="34" charset="0"/>
+            </a:endParaRPr>
           </a:p>
         </p:txBody>
       </p:sp>
     </p:spTree>
     <p:extLst>
       <p:ext uri="{BB962C8B-B14F-4D97-AF65-F5344CB8AC3E}">
-        <p14:creationId xmlns:p14="http://schemas.microsoft.com/office/powerpoint/2010/main" val="271747368"/>
+        <p14:creationId xmlns:p14="http://schemas.microsoft.com/office/powerpoint/2010/main" val="235985688"/>
       </p:ext>
     </p:extLst>
   </p:cSld>
@@ -7840,7 +7673,7 @@
           <p:cNvPr id="4" name="Title 3">
             <a:extLst>
               <a:ext uri="{FF2B5EF4-FFF2-40B4-BE49-F238E27FC236}">
-                <a16:creationId xmlns:a16="http://schemas.microsoft.com/office/drawing/2014/main" id="{B12A042D-321B-4746-83A3-B71D8C10D668}"/>
+                <a16:creationId xmlns:a16="http://schemas.microsoft.com/office/drawing/2014/main" id="{A6C66415-1492-4BAB-86E4-85BAECF02E41}"/>
               </a:ext>
             </a:extLst>
           </p:cNvPr>
@@ -7851,22 +7684,463 @@
             <p:ph type="title"/>
           </p:nvPr>
         </p:nvSpPr>
-        <p:spPr/>
+        <p:spPr>
+          <a:xfrm>
+            <a:off x="8610600" y="2560320"/>
+            <a:ext cx="3200400" cy="868680"/>
+          </a:xfrm>
+        </p:spPr>
         <p:txBody>
           <a:bodyPr/>
           <a:lstStyle/>
           <a:p>
             <a:r>
               <a:rPr lang="en-US" dirty="0"/>
-              <a:t>				Q &amp; A</a:t>
-            </a:r>
-          </a:p>
-        </p:txBody>
-      </p:sp>
+              <a:t>Login Page</a:t>
+            </a:r>
+          </a:p>
+        </p:txBody>
+      </p:sp>
+      <p:pic>
+        <p:nvPicPr>
+          <p:cNvPr id="8" name="Content Placeholder 7">
+            <a:extLst>
+              <a:ext uri="{FF2B5EF4-FFF2-40B4-BE49-F238E27FC236}">
+                <a16:creationId xmlns:a16="http://schemas.microsoft.com/office/drawing/2014/main" id="{E08A118F-0D4D-4572-AEE3-885A0F7FB6FA}"/>
+              </a:ext>
+            </a:extLst>
+          </p:cNvPr>
+          <p:cNvPicPr>
+            <a:picLocks noGrp="1" noChangeAspect="1"/>
+          </p:cNvPicPr>
+          <p:nvPr>
+            <p:ph idx="1"/>
+          </p:nvPr>
+        </p:nvPicPr>
+        <p:blipFill>
+          <a:blip r:embed="rId2">
+            <a:extLst>
+              <a:ext uri="{28A0092B-C50C-407E-A947-70E740481C1C}">
+                <a14:useLocalDpi xmlns:a14="http://schemas.microsoft.com/office/drawing/2010/main" val="0"/>
+              </a:ext>
+            </a:extLst>
+          </a:blip>
+          <a:stretch>
+            <a:fillRect/>
+          </a:stretch>
+        </p:blipFill>
+        <p:spPr>
+          <a:xfrm>
+            <a:off x="762000" y="932448"/>
+            <a:ext cx="6711950" cy="4993104"/>
+          </a:xfrm>
+        </p:spPr>
+      </p:pic>
     </p:spTree>
     <p:extLst>
       <p:ext uri="{BB962C8B-B14F-4D97-AF65-F5344CB8AC3E}">
-        <p14:creationId xmlns:p14="http://schemas.microsoft.com/office/powerpoint/2010/main" val="2648735212"/>
+        <p14:creationId xmlns:p14="http://schemas.microsoft.com/office/powerpoint/2010/main" val="727663477"/>
+      </p:ext>
+    </p:extLst>
+  </p:cSld>
+  <p:clrMapOvr>
+    <a:masterClrMapping/>
+  </p:clrMapOvr>
+</p:sld>
+</file>
+
+<file path=ppt/slides/slide26.xml><?xml version="1.0" encoding="utf-8"?>
+<p:sld xmlns:a="http://schemas.openxmlformats.org/drawingml/2006/main" xmlns:r="http://schemas.openxmlformats.org/officeDocument/2006/relationships" xmlns:p="http://schemas.openxmlformats.org/presentationml/2006/main">
+  <p:cSld>
+    <p:spTree>
+      <p:nvGrpSpPr>
+        <p:cNvPr id="1" name=""/>
+        <p:cNvGrpSpPr/>
+        <p:nvPr/>
+      </p:nvGrpSpPr>
+      <p:grpSpPr>
+        <a:xfrm>
+          <a:off x="0" y="0"/>
+          <a:ext cx="0" cy="0"/>
+          <a:chOff x="0" y="0"/>
+          <a:chExt cx="0" cy="0"/>
+        </a:xfrm>
+      </p:grpSpPr>
+      <p:sp>
+        <p:nvSpPr>
+          <p:cNvPr id="4" name="Title 3">
+            <a:extLst>
+              <a:ext uri="{FF2B5EF4-FFF2-40B4-BE49-F238E27FC236}">
+                <a16:creationId xmlns:a16="http://schemas.microsoft.com/office/drawing/2014/main" id="{82E84898-AA01-467D-83CA-FEB09F7BD2BE}"/>
+              </a:ext>
+            </a:extLst>
+          </p:cNvPr>
+          <p:cNvSpPr>
+            <a:spLocks noGrp="1"/>
+          </p:cNvSpPr>
+          <p:nvPr>
+            <p:ph type="title"/>
+          </p:nvPr>
+        </p:nvSpPr>
+        <p:spPr>
+          <a:xfrm>
+            <a:off x="8717281" y="2666999"/>
+            <a:ext cx="3200400" cy="762000"/>
+          </a:xfrm>
+        </p:spPr>
+        <p:txBody>
+          <a:bodyPr/>
+          <a:lstStyle/>
+          <a:p>
+            <a:r>
+              <a:rPr lang="en-US" dirty="0"/>
+              <a:t>Home Page</a:t>
+            </a:r>
+          </a:p>
+        </p:txBody>
+      </p:sp>
+      <p:pic>
+        <p:nvPicPr>
+          <p:cNvPr id="8" name="Content Placeholder 7">
+            <a:extLst>
+              <a:ext uri="{FF2B5EF4-FFF2-40B4-BE49-F238E27FC236}">
+                <a16:creationId xmlns:a16="http://schemas.microsoft.com/office/drawing/2014/main" id="{CC5D2AB9-E1E4-4F61-B917-492319BA206C}"/>
+              </a:ext>
+            </a:extLst>
+          </p:cNvPr>
+          <p:cNvPicPr>
+            <a:picLocks noGrp="1" noChangeAspect="1"/>
+          </p:cNvPicPr>
+          <p:nvPr>
+            <p:ph idx="1"/>
+          </p:nvPr>
+        </p:nvPicPr>
+        <p:blipFill>
+          <a:blip r:embed="rId2">
+            <a:extLst>
+              <a:ext uri="{28A0092B-C50C-407E-A947-70E740481C1C}">
+                <a14:useLocalDpi xmlns:a14="http://schemas.microsoft.com/office/drawing/2010/main" val="0"/>
+              </a:ext>
+            </a:extLst>
+          </a:blip>
+          <a:stretch>
+            <a:fillRect/>
+          </a:stretch>
+        </p:blipFill>
+        <p:spPr>
+          <a:xfrm>
+            <a:off x="274319" y="624839"/>
+            <a:ext cx="7953523" cy="5608319"/>
+          </a:xfrm>
+        </p:spPr>
+      </p:pic>
+    </p:spTree>
+    <p:extLst>
+      <p:ext uri="{BB962C8B-B14F-4D97-AF65-F5344CB8AC3E}">
+        <p14:creationId xmlns:p14="http://schemas.microsoft.com/office/powerpoint/2010/main" val="4238499242"/>
+      </p:ext>
+    </p:extLst>
+  </p:cSld>
+  <p:clrMapOvr>
+    <a:masterClrMapping/>
+  </p:clrMapOvr>
+</p:sld>
+</file>
+
+<file path=ppt/slides/slide27.xml><?xml version="1.0" encoding="utf-8"?>
+<p:sld xmlns:a="http://schemas.openxmlformats.org/drawingml/2006/main" xmlns:r="http://schemas.openxmlformats.org/officeDocument/2006/relationships" xmlns:p="http://schemas.openxmlformats.org/presentationml/2006/main">
+  <p:cSld>
+    <p:spTree>
+      <p:nvGrpSpPr>
+        <p:cNvPr id="1" name=""/>
+        <p:cNvGrpSpPr/>
+        <p:nvPr/>
+      </p:nvGrpSpPr>
+      <p:grpSpPr>
+        <a:xfrm>
+          <a:off x="0" y="0"/>
+          <a:ext cx="0" cy="0"/>
+          <a:chOff x="0" y="0"/>
+          <a:chExt cx="0" cy="0"/>
+        </a:xfrm>
+      </p:grpSpPr>
+      <p:sp>
+        <p:nvSpPr>
+          <p:cNvPr id="4" name="Title 3">
+            <a:extLst>
+              <a:ext uri="{FF2B5EF4-FFF2-40B4-BE49-F238E27FC236}">
+                <a16:creationId xmlns:a16="http://schemas.microsoft.com/office/drawing/2014/main" id="{27F34532-1560-4BB7-B937-C3D51B8DDFFA}"/>
+              </a:ext>
+            </a:extLst>
+          </p:cNvPr>
+          <p:cNvSpPr>
+            <a:spLocks noGrp="1"/>
+          </p:cNvSpPr>
+          <p:nvPr>
+            <p:ph type="title"/>
+          </p:nvPr>
+        </p:nvSpPr>
+        <p:spPr>
+          <a:xfrm>
+            <a:off x="8656320" y="2509837"/>
+            <a:ext cx="3200400" cy="685800"/>
+          </a:xfrm>
+        </p:spPr>
+        <p:txBody>
+          <a:bodyPr/>
+          <a:lstStyle/>
+          <a:p>
+            <a:r>
+              <a:rPr lang="en-US" dirty="0"/>
+              <a:t>Tasks Page</a:t>
+            </a:r>
+          </a:p>
+        </p:txBody>
+      </p:sp>
+      <p:pic>
+        <p:nvPicPr>
+          <p:cNvPr id="8" name="Content Placeholder 7">
+            <a:extLst>
+              <a:ext uri="{FF2B5EF4-FFF2-40B4-BE49-F238E27FC236}">
+                <a16:creationId xmlns:a16="http://schemas.microsoft.com/office/drawing/2014/main" id="{1F60B22E-19E2-4D07-B847-7B5440416417}"/>
+              </a:ext>
+            </a:extLst>
+          </p:cNvPr>
+          <p:cNvPicPr>
+            <a:picLocks noGrp="1" noChangeAspect="1"/>
+          </p:cNvPicPr>
+          <p:nvPr>
+            <p:ph idx="1"/>
+          </p:nvPr>
+        </p:nvPicPr>
+        <p:blipFill>
+          <a:blip r:embed="rId2">
+            <a:extLst>
+              <a:ext uri="{28A0092B-C50C-407E-A947-70E740481C1C}">
+                <a14:useLocalDpi xmlns:a14="http://schemas.microsoft.com/office/drawing/2010/main" val="0"/>
+              </a:ext>
+            </a:extLst>
+          </a:blip>
+          <a:stretch>
+            <a:fillRect/>
+          </a:stretch>
+        </p:blipFill>
+        <p:spPr>
+          <a:xfrm>
+            <a:off x="533400" y="640882"/>
+            <a:ext cx="7010400" cy="5576235"/>
+          </a:xfrm>
+        </p:spPr>
+      </p:pic>
+    </p:spTree>
+    <p:extLst>
+      <p:ext uri="{BB962C8B-B14F-4D97-AF65-F5344CB8AC3E}">
+        <p14:creationId xmlns:p14="http://schemas.microsoft.com/office/powerpoint/2010/main" val="2336139826"/>
+      </p:ext>
+    </p:extLst>
+  </p:cSld>
+  <p:clrMapOvr>
+    <a:masterClrMapping/>
+  </p:clrMapOvr>
+</p:sld>
+</file>
+
+<file path=ppt/slides/slide28.xml><?xml version="1.0" encoding="utf-8"?>
+<p:sld xmlns:a="http://schemas.openxmlformats.org/drawingml/2006/main" xmlns:r="http://schemas.openxmlformats.org/officeDocument/2006/relationships" xmlns:p="http://schemas.openxmlformats.org/presentationml/2006/main">
+  <p:cSld>
+    <p:spTree>
+      <p:nvGrpSpPr>
+        <p:cNvPr id="1" name=""/>
+        <p:cNvGrpSpPr/>
+        <p:nvPr/>
+      </p:nvGrpSpPr>
+      <p:grpSpPr>
+        <a:xfrm>
+          <a:off x="0" y="0"/>
+          <a:ext cx="0" cy="0"/>
+          <a:chOff x="0" y="0"/>
+          <a:chExt cx="0" cy="0"/>
+        </a:xfrm>
+      </p:grpSpPr>
+      <p:sp>
+        <p:nvSpPr>
+          <p:cNvPr id="4" name="Title 3">
+            <a:extLst>
+              <a:ext uri="{FF2B5EF4-FFF2-40B4-BE49-F238E27FC236}">
+                <a16:creationId xmlns:a16="http://schemas.microsoft.com/office/drawing/2014/main" id="{5C6850DF-037C-4809-A29F-F0469D033375}"/>
+              </a:ext>
+            </a:extLst>
+          </p:cNvPr>
+          <p:cNvSpPr>
+            <a:spLocks noGrp="1"/>
+          </p:cNvSpPr>
+          <p:nvPr>
+            <p:ph type="title"/>
+          </p:nvPr>
+        </p:nvSpPr>
+        <p:spPr>
+          <a:xfrm>
+            <a:off x="8549640" y="2453640"/>
+            <a:ext cx="3200400" cy="975360"/>
+          </a:xfrm>
+        </p:spPr>
+        <p:txBody>
+          <a:bodyPr/>
+          <a:lstStyle/>
+          <a:p>
+            <a:r>
+              <a:rPr lang="en-US" dirty="0"/>
+              <a:t>Analytics Page</a:t>
+            </a:r>
+          </a:p>
+        </p:txBody>
+      </p:sp>
+      <p:pic>
+        <p:nvPicPr>
+          <p:cNvPr id="8" name="Content Placeholder 7">
+            <a:extLst>
+              <a:ext uri="{FF2B5EF4-FFF2-40B4-BE49-F238E27FC236}">
+                <a16:creationId xmlns:a16="http://schemas.microsoft.com/office/drawing/2014/main" id="{53DA49C0-7169-4ED2-961F-71B65852D34C}"/>
+              </a:ext>
+            </a:extLst>
+          </p:cNvPr>
+          <p:cNvPicPr>
+            <a:picLocks noGrp="1" noChangeAspect="1"/>
+          </p:cNvPicPr>
+          <p:nvPr>
+            <p:ph idx="1"/>
+          </p:nvPr>
+        </p:nvPicPr>
+        <p:blipFill>
+          <a:blip r:embed="rId2">
+            <a:extLst>
+              <a:ext uri="{28A0092B-C50C-407E-A947-70E740481C1C}">
+                <a14:useLocalDpi xmlns:a14="http://schemas.microsoft.com/office/drawing/2010/main" val="0"/>
+              </a:ext>
+            </a:extLst>
+          </a:blip>
+          <a:stretch>
+            <a:fillRect/>
+          </a:stretch>
+        </p:blipFill>
+        <p:spPr>
+          <a:xfrm>
+            <a:off x="441960" y="855075"/>
+            <a:ext cx="7467204" cy="5147850"/>
+          </a:xfrm>
+        </p:spPr>
+      </p:pic>
+    </p:spTree>
+    <p:extLst>
+      <p:ext uri="{BB962C8B-B14F-4D97-AF65-F5344CB8AC3E}">
+        <p14:creationId xmlns:p14="http://schemas.microsoft.com/office/powerpoint/2010/main" val="1527877849"/>
+      </p:ext>
+    </p:extLst>
+  </p:cSld>
+  <p:clrMapOvr>
+    <a:masterClrMapping/>
+  </p:clrMapOvr>
+</p:sld>
+</file>
+
+<file path=ppt/slides/slide29.xml><?xml version="1.0" encoding="utf-8"?>
+<p:sld xmlns:a="http://schemas.openxmlformats.org/drawingml/2006/main" xmlns:r="http://schemas.openxmlformats.org/officeDocument/2006/relationships" xmlns:p="http://schemas.openxmlformats.org/presentationml/2006/main">
+  <p:cSld>
+    <p:spTree>
+      <p:nvGrpSpPr>
+        <p:cNvPr id="1" name=""/>
+        <p:cNvGrpSpPr/>
+        <p:nvPr/>
+      </p:nvGrpSpPr>
+      <p:grpSpPr>
+        <a:xfrm>
+          <a:off x="0" y="0"/>
+          <a:ext cx="0" cy="0"/>
+          <a:chOff x="0" y="0"/>
+          <a:chExt cx="0" cy="0"/>
+        </a:xfrm>
+      </p:grpSpPr>
+      <p:sp>
+        <p:nvSpPr>
+          <p:cNvPr id="4" name="Title 3">
+            <a:extLst>
+              <a:ext uri="{FF2B5EF4-FFF2-40B4-BE49-F238E27FC236}">
+                <a16:creationId xmlns:a16="http://schemas.microsoft.com/office/drawing/2014/main" id="{1682A2F5-CF04-4CE6-B1F7-16136421BA4D}"/>
+              </a:ext>
+            </a:extLst>
+          </p:cNvPr>
+          <p:cNvSpPr>
+            <a:spLocks noGrp="1"/>
+          </p:cNvSpPr>
+          <p:nvPr>
+            <p:ph type="title"/>
+          </p:nvPr>
+        </p:nvSpPr>
+        <p:spPr>
+          <a:xfrm>
+            <a:off x="8619088" y="2406377"/>
+            <a:ext cx="3200400" cy="1022623"/>
+          </a:xfrm>
+        </p:spPr>
+        <p:txBody>
+          <a:bodyPr>
+            <a:normAutofit fontScale="90000"/>
+          </a:bodyPr>
+          <a:lstStyle/>
+          <a:p>
+            <a:r>
+              <a:rPr lang="en-US" dirty="0"/>
+              <a:t>Project Contributors</a:t>
+            </a:r>
+            <a:br>
+              <a:rPr lang="en-US" dirty="0"/>
+            </a:br>
+            <a:r>
+              <a:rPr lang="en-US" dirty="0"/>
+              <a:t>Page</a:t>
+            </a:r>
+          </a:p>
+        </p:txBody>
+      </p:sp>
+      <p:pic>
+        <p:nvPicPr>
+          <p:cNvPr id="8" name="Content Placeholder 7">
+            <a:extLst>
+              <a:ext uri="{FF2B5EF4-FFF2-40B4-BE49-F238E27FC236}">
+                <a16:creationId xmlns:a16="http://schemas.microsoft.com/office/drawing/2014/main" id="{2C2C943A-CC5E-4295-B1DF-B667F5D2EC75}"/>
+              </a:ext>
+            </a:extLst>
+          </p:cNvPr>
+          <p:cNvPicPr>
+            <a:picLocks noGrp="1" noChangeAspect="1"/>
+          </p:cNvPicPr>
+          <p:nvPr>
+            <p:ph idx="1"/>
+          </p:nvPr>
+        </p:nvPicPr>
+        <p:blipFill>
+          <a:blip r:embed="rId2">
+            <a:extLst>
+              <a:ext uri="{28A0092B-C50C-407E-A947-70E740481C1C}">
+                <a14:useLocalDpi xmlns:a14="http://schemas.microsoft.com/office/drawing/2010/main" val="0"/>
+              </a:ext>
+            </a:extLst>
+          </a:blip>
+          <a:stretch>
+            <a:fillRect/>
+          </a:stretch>
+        </p:blipFill>
+        <p:spPr>
+          <a:xfrm>
+            <a:off x="533400" y="540136"/>
+            <a:ext cx="7208520" cy="5777728"/>
+          </a:xfrm>
+        </p:spPr>
+      </p:pic>
+    </p:spTree>
+    <p:extLst>
+      <p:ext uri="{BB962C8B-B14F-4D97-AF65-F5344CB8AC3E}">
+        <p14:creationId xmlns:p14="http://schemas.microsoft.com/office/powerpoint/2010/main" val="750258580"/>
       </p:ext>
     </p:extLst>
   </p:cSld>
@@ -8192,6 +8466,298 @@
     <p:extLst>
       <p:ext uri="{BB962C8B-B14F-4D97-AF65-F5344CB8AC3E}">
         <p14:creationId xmlns:p14="http://schemas.microsoft.com/office/powerpoint/2010/main" val="20516193"/>
+      </p:ext>
+    </p:extLst>
+  </p:cSld>
+  <p:clrMapOvr>
+    <a:masterClrMapping/>
+  </p:clrMapOvr>
+</p:sld>
+</file>
+
+<file path=ppt/slides/slide30.xml><?xml version="1.0" encoding="utf-8"?>
+<p:sld xmlns:a="http://schemas.openxmlformats.org/drawingml/2006/main" xmlns:r="http://schemas.openxmlformats.org/officeDocument/2006/relationships" xmlns:p="http://schemas.openxmlformats.org/presentationml/2006/main">
+  <p:cSld>
+    <p:spTree>
+      <p:nvGrpSpPr>
+        <p:cNvPr id="1" name=""/>
+        <p:cNvGrpSpPr/>
+        <p:nvPr/>
+      </p:nvGrpSpPr>
+      <p:grpSpPr>
+        <a:xfrm>
+          <a:off x="0" y="0"/>
+          <a:ext cx="0" cy="0"/>
+          <a:chOff x="0" y="0"/>
+          <a:chExt cx="0" cy="0"/>
+        </a:xfrm>
+      </p:grpSpPr>
+      <p:sp>
+        <p:nvSpPr>
+          <p:cNvPr id="2" name="Title 1">
+            <a:extLst>
+              <a:ext uri="{FF2B5EF4-FFF2-40B4-BE49-F238E27FC236}">
+                <a16:creationId xmlns:a16="http://schemas.microsoft.com/office/drawing/2014/main" id="{D0325DC4-1DFD-4FC6-A884-9A5E62D118CF}"/>
+              </a:ext>
+            </a:extLst>
+          </p:cNvPr>
+          <p:cNvSpPr>
+            <a:spLocks noGrp="1"/>
+          </p:cNvSpPr>
+          <p:nvPr>
+            <p:ph type="title"/>
+          </p:nvPr>
+        </p:nvSpPr>
+        <p:spPr/>
+        <p:txBody>
+          <a:bodyPr/>
+          <a:lstStyle/>
+          <a:p>
+            <a:r>
+              <a:rPr lang="en-US" dirty="0"/>
+              <a:t>Summary</a:t>
+            </a:r>
+          </a:p>
+        </p:txBody>
+      </p:sp>
+      <p:sp>
+        <p:nvSpPr>
+          <p:cNvPr id="4" name="Rectangle 1">
+            <a:extLst>
+              <a:ext uri="{FF2B5EF4-FFF2-40B4-BE49-F238E27FC236}">
+                <a16:creationId xmlns:a16="http://schemas.microsoft.com/office/drawing/2014/main" id="{08130F10-A9D9-48A0-B66B-AABF0F591093}"/>
+              </a:ext>
+            </a:extLst>
+          </p:cNvPr>
+          <p:cNvSpPr>
+            <a:spLocks noGrp="1" noChangeArrowheads="1"/>
+          </p:cNvSpPr>
+          <p:nvPr>
+            <p:ph idx="1"/>
+          </p:nvPr>
+        </p:nvSpPr>
+        <p:spPr bwMode="auto">
+          <a:xfrm>
+            <a:off x="1069848" y="2760152"/>
+            <a:ext cx="9887712" cy="2741776"/>
+          </a:xfrm>
+          <a:prstGeom prst="rect">
+            <a:avLst/>
+          </a:prstGeom>
+          <a:noFill/>
+          <a:ln>
+            <a:noFill/>
+          </a:ln>
+          <a:effectLst/>
+          <a:extLst>
+            <a:ext uri="{909E8E84-426E-40DD-AFC4-6F175D3DCCD1}">
+              <a14:hiddenFill xmlns:a14="http://schemas.microsoft.com/office/drawing/2010/main">
+                <a:solidFill>
+                  <a:schemeClr val="accent1"/>
+                </a:solidFill>
+              </a14:hiddenFill>
+            </a:ext>
+            <a:ext uri="{91240B29-F687-4F45-9708-019B960494DF}">
+              <a14:hiddenLine xmlns:a14="http://schemas.microsoft.com/office/drawing/2010/main" w="9525">
+                <a:solidFill>
+                  <a:schemeClr val="tx1"/>
+                </a:solidFill>
+                <a:miter lim="800000"/>
+                <a:headEnd/>
+                <a:tailEnd/>
+              </a14:hiddenLine>
+            </a:ext>
+            <a:ext uri="{AF507438-7753-43E0-B8FC-AC1667EBCBE1}">
+              <a14:hiddenEffects xmlns:a14="http://schemas.microsoft.com/office/drawing/2010/main">
+                <a:effectLst>
+                  <a:outerShdw dist="35921" dir="2700000" algn="ctr" rotWithShape="0">
+                    <a:schemeClr val="bg2"/>
+                  </a:outerShdw>
+                </a:effectLst>
+              </a14:hiddenEffects>
+            </a:ext>
+          </a:extLst>
+        </p:spPr>
+        <p:txBody>
+          <a:bodyPr vert="horz" wrap="square" lIns="91440" tIns="45720" rIns="91440" bIns="45720" numCol="1" anchor="ctr" anchorCtr="0" compatLnSpc="1">
+            <a:prstTxWarp prst="textNoShape">
+              <a:avLst/>
+            </a:prstTxWarp>
+            <a:spAutoFit/>
+          </a:bodyPr>
+          <a:lstStyle/>
+          <a:p>
+            <a:pPr eaLnBrk="0" fontAlgn="base" hangingPunct="0">
+              <a:lnSpc>
+                <a:spcPct val="250000"/>
+              </a:lnSpc>
+              <a:spcBef>
+                <a:spcPct val="0"/>
+              </a:spcBef>
+              <a:spcAft>
+                <a:spcPct val="0"/>
+              </a:spcAft>
+              <a:buClrTx/>
+              <a:buSzTx/>
+            </a:pPr>
+            <a:r>
+              <a:rPr kumimoji="0" lang="en-US" altLang="en-US" sz="1800" i="0" u="none" strike="noStrike" cap="none" normalizeH="0" baseline="0" dirty="0">
+                <a:ln>
+                  <a:noFill/>
+                </a:ln>
+                <a:solidFill>
+                  <a:schemeClr val="tx1"/>
+                </a:solidFill>
+                <a:effectLst/>
+                <a:latin typeface="Arial" panose="020B0604020202020204" pitchFamily="34" charset="0"/>
+              </a:rPr>
+              <a:t>Project Overview</a:t>
+            </a:r>
+          </a:p>
+          <a:p>
+            <a:pPr eaLnBrk="0" fontAlgn="base" hangingPunct="0">
+              <a:lnSpc>
+                <a:spcPct val="250000"/>
+              </a:lnSpc>
+              <a:spcBef>
+                <a:spcPct val="0"/>
+              </a:spcBef>
+              <a:spcAft>
+                <a:spcPct val="0"/>
+              </a:spcAft>
+              <a:buClrTx/>
+              <a:buSzTx/>
+            </a:pPr>
+            <a:r>
+              <a:rPr lang="en-US" altLang="en-US" sz="1800" dirty="0">
+                <a:latin typeface="Arial" panose="020B0604020202020204" pitchFamily="34" charset="0"/>
+              </a:rPr>
+              <a:t>Methodology</a:t>
+            </a:r>
+          </a:p>
+          <a:p>
+            <a:pPr eaLnBrk="0" fontAlgn="base" hangingPunct="0">
+              <a:lnSpc>
+                <a:spcPct val="250000"/>
+              </a:lnSpc>
+              <a:spcBef>
+                <a:spcPct val="0"/>
+              </a:spcBef>
+              <a:spcAft>
+                <a:spcPct val="0"/>
+              </a:spcAft>
+              <a:buClrTx/>
+              <a:buSzTx/>
+            </a:pPr>
+            <a:r>
+              <a:rPr kumimoji="0" lang="en-US" altLang="en-US" sz="1800" i="0" u="none" strike="noStrike" cap="none" normalizeH="0" baseline="0" dirty="0">
+                <a:ln>
+                  <a:noFill/>
+                </a:ln>
+                <a:solidFill>
+                  <a:schemeClr val="tx1"/>
+                </a:solidFill>
+                <a:effectLst/>
+                <a:latin typeface="Arial" panose="020B0604020202020204" pitchFamily="34" charset="0"/>
+              </a:rPr>
+              <a:t>System Design</a:t>
+            </a:r>
+          </a:p>
+          <a:p>
+            <a:pPr eaLnBrk="0" fontAlgn="base" hangingPunct="0">
+              <a:lnSpc>
+                <a:spcPct val="250000"/>
+              </a:lnSpc>
+              <a:spcBef>
+                <a:spcPct val="0"/>
+              </a:spcBef>
+              <a:spcAft>
+                <a:spcPct val="0"/>
+              </a:spcAft>
+              <a:buClrTx/>
+              <a:buSzTx/>
+            </a:pPr>
+            <a:r>
+              <a:rPr lang="en-US" altLang="en-US" sz="1800" dirty="0">
+                <a:latin typeface="Arial" panose="020B0604020202020204" pitchFamily="34" charset="0"/>
+              </a:rPr>
+              <a:t>System Implementation</a:t>
+            </a:r>
+            <a:endParaRPr kumimoji="0" lang="en-US" altLang="en-US" sz="1800" i="0" u="none" strike="noStrike" cap="none" normalizeH="0" baseline="0" dirty="0">
+              <a:ln>
+                <a:noFill/>
+              </a:ln>
+              <a:solidFill>
+                <a:schemeClr val="tx1"/>
+              </a:solidFill>
+              <a:effectLst/>
+              <a:latin typeface="Arial" panose="020B0604020202020204" pitchFamily="34" charset="0"/>
+            </a:endParaRPr>
+          </a:p>
+        </p:txBody>
+      </p:sp>
+    </p:spTree>
+    <p:extLst>
+      <p:ext uri="{BB962C8B-B14F-4D97-AF65-F5344CB8AC3E}">
+        <p14:creationId xmlns:p14="http://schemas.microsoft.com/office/powerpoint/2010/main" val="271747368"/>
+      </p:ext>
+    </p:extLst>
+  </p:cSld>
+  <p:clrMapOvr>
+    <a:masterClrMapping/>
+  </p:clrMapOvr>
+</p:sld>
+</file>
+
+<file path=ppt/slides/slide31.xml><?xml version="1.0" encoding="utf-8"?>
+<p:sld xmlns:a="http://schemas.openxmlformats.org/drawingml/2006/main" xmlns:r="http://schemas.openxmlformats.org/officeDocument/2006/relationships" xmlns:p="http://schemas.openxmlformats.org/presentationml/2006/main">
+  <p:cSld>
+    <p:spTree>
+      <p:nvGrpSpPr>
+        <p:cNvPr id="1" name=""/>
+        <p:cNvGrpSpPr/>
+        <p:nvPr/>
+      </p:nvGrpSpPr>
+      <p:grpSpPr>
+        <a:xfrm>
+          <a:off x="0" y="0"/>
+          <a:ext cx="0" cy="0"/>
+          <a:chOff x="0" y="0"/>
+          <a:chExt cx="0" cy="0"/>
+        </a:xfrm>
+      </p:grpSpPr>
+      <p:sp>
+        <p:nvSpPr>
+          <p:cNvPr id="4" name="Title 3">
+            <a:extLst>
+              <a:ext uri="{FF2B5EF4-FFF2-40B4-BE49-F238E27FC236}">
+                <a16:creationId xmlns:a16="http://schemas.microsoft.com/office/drawing/2014/main" id="{B12A042D-321B-4746-83A3-B71D8C10D668}"/>
+              </a:ext>
+            </a:extLst>
+          </p:cNvPr>
+          <p:cNvSpPr>
+            <a:spLocks noGrp="1"/>
+          </p:cNvSpPr>
+          <p:nvPr>
+            <p:ph type="title"/>
+          </p:nvPr>
+        </p:nvSpPr>
+        <p:spPr/>
+        <p:txBody>
+          <a:bodyPr/>
+          <a:lstStyle/>
+          <a:p>
+            <a:r>
+              <a:rPr lang="en-US" dirty="0"/>
+              <a:t>				Q &amp; A</a:t>
+            </a:r>
+          </a:p>
+        </p:txBody>
+      </p:sp>
+    </p:spTree>
+    <p:extLst>
+      <p:ext uri="{BB962C8B-B14F-4D97-AF65-F5344CB8AC3E}">
+        <p14:creationId xmlns:p14="http://schemas.microsoft.com/office/powerpoint/2010/main" val="2648735212"/>
       </p:ext>
     </p:extLst>
   </p:cSld>

</xml_diff>